<commit_message>
temporary changes before pitch
</commit_message>
<xml_diff>
--- a/ChhotuAI_Investor_Pitch.pptx
+++ b/ChhotuAI_Investor_Pitch.pptx
@@ -2,17 +2,17 @@
 <file path=ppt/presentation.xml><?xml version="1.0" encoding="utf-8"?>
 <p:presentation xmlns:p="http://schemas.openxmlformats.org/presentationml/2006/main">
   <p:sldMasterIdLst>
-    <p:sldMasterId xmlns:r="http://schemas.openxmlformats.org/officeDocument/2006/relationships" id="2147483648" r:id="Ra6475e40778c437b"/>
+    <p:sldMasterId xmlns:r="http://schemas.openxmlformats.org/officeDocument/2006/relationships" id="2147483648" r:id="R16dbcefe54464cce"/>
   </p:sldMasterIdLst>
   <p:notesMasterIdLst>
-    <p:notesMasterId xmlns:r="http://schemas.openxmlformats.org/officeDocument/2006/relationships" r:id="R2d267f82ab534894"/>
+    <p:notesMasterId xmlns:r="http://schemas.openxmlformats.org/officeDocument/2006/relationships" r:id="R4ba6d48bdcac465a"/>
   </p:notesMasterIdLst>
   <p:sldIdLst>
-    <p:sldId xmlns:r="http://schemas.openxmlformats.org/officeDocument/2006/relationships" id="256" r:id="Rada81ce61aa0418d"/>
-    <p:sldId xmlns:r="http://schemas.openxmlformats.org/officeDocument/2006/relationships" id="257" r:id="R65a4b97cacde44f8"/>
-    <p:sldId xmlns:r="http://schemas.openxmlformats.org/officeDocument/2006/relationships" id="258" r:id="Rc896b5cab5484545"/>
-    <p:sldId xmlns:r="http://schemas.openxmlformats.org/officeDocument/2006/relationships" id="259" r:id="R62c83681f6e8464f"/>
-    <p:sldId xmlns:r="http://schemas.openxmlformats.org/officeDocument/2006/relationships" id="260" r:id="R346aa9e050dc4127"/>
+    <p:sldId xmlns:r="http://schemas.openxmlformats.org/officeDocument/2006/relationships" id="256" r:id="R5ef89145a4424e99"/>
+    <p:sldId xmlns:r="http://schemas.openxmlformats.org/officeDocument/2006/relationships" id="257" r:id="Ra7ef4004299649b3"/>
+    <p:sldId xmlns:r="http://schemas.openxmlformats.org/officeDocument/2006/relationships" id="258" r:id="Re2a493cfce594b73"/>
+    <p:sldId xmlns:r="http://schemas.openxmlformats.org/officeDocument/2006/relationships" id="259" r:id="Rb8f4248a7f2b4488"/>
+    <p:sldId xmlns:r="http://schemas.openxmlformats.org/officeDocument/2006/relationships" id="260" r:id="R2fa8601092204f62"/>
   </p:sldIdLst>
   <p:sldSz cx="12192000" cy="6858000"/>
   <p:notesSz cx="6858000" cy="9144000"/>
@@ -546,7 +546,7 @@
           <a:lstStyle xmlns:a="http://schemas.openxmlformats.org/drawingml/2006/main"/>
           <a:p xmlns:a="http://schemas.openxmlformats.org/drawingml/2006/main">
             <a:r>
-              <a:t>Speaker 1: Our first market is not retail alone. MoSPI estimates 2.28 crore unincorporated trade establishments in 2023-24; the trade sector covers wholesale and retail, which is the right official frame for hardware retailers, wholesalers, stockists and many distributors. MoSPI also reports only 26.7 percent internet use across the covered unincorporated sector. The Rs 55,244.31 crore figure is not all market receivables: it is the value of formal delayed-payment applications filed by micro and small enterprises on MSME Samadhaan through 31 December 2025. ASUSE excludes incorporated businesses and construction activity itself, so present these as a defensible lower-bound trade signal, not Chhotu.ai's complete TAM.</a:t>
+              <a:t>Speaker 1: Our first market is not retail alone. MoSPI estimates 2.28 crore unincorporated trade establishments in 2023–24; trade covers wholesale and retail. Only 34.7% of trade establishments used the internet for entrepreneurial work. The Rs 55,244.31 crore figure is not the whole receivables market: it is the value of formal delayed-payment applications filed by micro and small enterprises on MSME Samadhaan through 31 December 2025. Together, the numbers show a very large operating base, uneven digitisation, and a costly credit problem.</a:t>
             </a:r>
           </a:p>
           <a:p xmlns:a="http://schemas.openxmlformats.org/drawingml/2006/main">
@@ -562,11 +562,6 @@
           <a:p xmlns:a="http://schemas.openxmlformats.org/drawingml/2006/main">
             <a:r>
               <a:t>- https://mospi.gov.in/sites/default/files/publication_reports/ASUSE_2023_24_Full_Report-L.pdf</a:t>
-            </a:r>
-          </a:p>
-          <a:p xmlns:a="http://schemas.openxmlformats.org/drawingml/2006/main">
-            <a:r>
-              <a:t>- https://mospi.gov.in/sites/default/files/publication_reports/Factsheet_of_ASUSE_2023_24.pdf</a:t>
             </a:r>
           </a:p>
           <a:p xmlns:a="http://schemas.openxmlformats.org/drawingml/2006/main">
@@ -646,7 +641,7 @@
           <a:lstStyle xmlns:a="http://schemas.openxmlformats.org/drawingml/2006/main"/>
           <a:p xmlns:a="http://schemas.openxmlformats.org/drawingml/2006/main">
             <a:r>
-              <a:t>Speaker 2: Sarvam is not a logo slide; it is the interaction layer we actually use. Samvaad provides the live multilingual voice agent, code-mixed speech, streaming turns, interruption handling and calls to our grounded inventory, CRM and billing tools. Voice, web and WhatsApp are three interaction channels for the same agent and context, not a third model capability. Sarvam Vision powers document digitization across 23 languages: it extracts text, tables, layout and reading order from invoice photos and PDFs. Chhotu.ai then matches the extracted product, quantity, GST and cost fields against the shop's own catalogue and requires review before inventory changes. Sarvam states 11 Samvaad languages and sub-500ms latency; those are vendor-published figures.</a:t>
+              <a:t>Speaker 2: Sarvam is the interaction layer we actually use. Saaras v3 converts multilingual and code-mixed speech into text. Samvaad carries the live conversation, interruptions, context, and grounded calls to our inventory, CRM, billing, and reporting tools. Bulbul v3 speaks the verified result back to the owner. In the fallback path, Chhotu.ai calls Saaras and Bulbul directly. For supplier documents, Sarvam Vision digitises images and PDFs; our backend then maps product, quantity, GST, freight, and cost to the shop catalogue and keeps a review gate before stock changes. We do not use a separate generic translation service in the live voice path: code-mixed transcription, transliteration, and English-normalised tool parameters keep backend actions reliable.</a:t>
             </a:r>
           </a:p>
           <a:p xmlns:a="http://schemas.openxmlformats.org/drawingml/2006/main">
@@ -661,27 +656,42 @@
           </a:p>
           <a:p xmlns:a="http://schemas.openxmlformats.org/drawingml/2006/main">
             <a:r>
+              <a:t>- https://docs.sarvam.ai/api/getting-started/models</a:t>
+            </a:r>
+          </a:p>
+          <a:p xmlns:a="http://schemas.openxmlformats.org/drawingml/2006/main">
+            <a:r>
+              <a:t>- https://docs.sarvam.ai/api/getting-started/models/saaras</a:t>
+            </a:r>
+          </a:p>
+          <a:p xmlns:a="http://schemas.openxmlformats.org/drawingml/2006/main">
+            <a:r>
+              <a:t>- https://docs.sarvam.ai/api/getting-started/models/sarvam-vision</a:t>
+            </a:r>
+          </a:p>
+          <a:p xmlns:a="http://schemas.openxmlformats.org/drawingml/2006/main">
+            <a:r>
+              <a:t>- https://docs.sarvam.ai/api/api-guides-tutorials/document-digitization/overview</a:t>
+            </a:r>
+          </a:p>
+          <a:p xmlns:a="http://schemas.openxmlformats.org/drawingml/2006/main">
+            <a:r>
               <a:t>- https://www.sarvam.ai/products/conversational-agents</a:t>
             </a:r>
           </a:p>
           <a:p xmlns:a="http://schemas.openxmlformats.org/drawingml/2006/main">
             <a:r>
-              <a:t>- https://docs.sarvam.ai/api/getting-started/models/sarvam-vision</a:t>
-            </a:r>
-          </a:p>
-          <a:p xmlns:a="http://schemas.openxmlformats.org/drawingml/2006/main">
-            <a:r>
-              <a:t>- https://docs.sarvam.ai/api/api-guides-tutorials/document-digitization/overview</a:t>
-            </a:r>
-          </a:p>
-          <a:p xmlns:a="http://schemas.openxmlformats.org/drawingml/2006/main">
-            <a:r>
               <a:t>- /Users/faizansheikh/ChhotuAI/backend/sarvam_client.py</a:t>
             </a:r>
           </a:p>
           <a:p xmlns:a="http://schemas.openxmlformats.org/drawingml/2006/main">
             <a:r>
-              <a:t>- /Users/faizansheikh/ChhotuAI/backend/main.py</a:t>
+              <a:t>- /Users/faizansheikh/ChhotuAI/backend/samvaad_runtime.py</a:t>
+            </a:r>
+          </a:p>
+          <a:p xmlns:a="http://schemas.openxmlformats.org/drawingml/2006/main">
+            <a:r>
+              <a:t>- /Users/faizansheikh/ChhotuAI/frontend/src/samvaad.js</a:t>
             </a:r>
           </a:p>
           <a:p xmlns:a="http://schemas.openxmlformats.org/drawingml/2006/main">
@@ -756,7 +766,7 @@
           <a:lstStyle xmlns:a="http://schemas.openxmlformats.org/drawingml/2006/main"/>
           <a:p xmlns:a="http://schemas.openxmlformats.org/drawingml/2006/main">
             <a:r>
-              <a:t>Both: This is the live product for hardware and construction stores. Keep orders and provider-managed deliveries for the next slide because they are on the dev roadmap, not the production claim. The important technical point is that the agent never becomes the ledger: grounded backend tools validate and store every stock or money action.</a:t>
+              <a:t>Both: Everything on this slide is available in the current product: multilingual voice-led sales and purchases; inventory, stock and margin questions; customer credit and payment records; bills and reminders; and reviewed supplier-invoice digitisation. The grounded backend remains the system of record—Samvaad can request an action, but only validated tools write stock or money movements.</a:t>
             </a:r>
           </a:p>
           <a:p xmlns:a="http://schemas.openxmlformats.org/drawingml/2006/main">
@@ -856,7 +866,7 @@
           <a:lstStyle xmlns:a="http://schemas.openxmlformats.org/drawingml/2006/main"/>
           <a:p xmlns:a="http://schemas.openxmlformats.org/drawingml/2006/main">
             <a:r>
-              <a:t>Speaker 2: Phase 1 and Phase 2—manual order lifecycle and grounded Sarvam order tools—are implemented on dev and still require isolated preview acceptance before production. Later phases add dispatch, inbound customer calls, supplier restocking, invoice reconciliation and provider adapters. A 'Hey Chhotu' experience is feasible, but should be opt-in and privacy-preserving: use an on-device wake-word detector, then open the Samvaad session only after the local trigger. Reliable always-on listening is best delivered through an installed mobile/PWA, kiosk or native companion; ordinary mobile browsers may suspend background audio.</a:t>
+              <a:t>Speaker 2: This slide is explicitly the roadmap. Order lifecycle and grounded Sarvam order tools are in development on the dev branch and are not a current production claim. Provider-managed deliveries, supplier restocking calls, invoice reconciliation and warehouse-scale fulfilment analytics are planned phases. A 'Hey Chhotu' wake word is a future concept: it should be opt-in and privacy-preserving, with an on-device trigger that starts a Samvaad session only after activation.</a:t>
             </a:r>
           </a:p>
           <a:p xmlns:a="http://schemas.openxmlformats.org/drawingml/2006/main">
@@ -949,7 +959,7 @@
   </p:cSld>
   <p:clrMap bg1="lt1" tx1="dk1" bg2="lt2" tx2="dk2" accent1="accent1" accent2="accent2" accent3="accent3" accent4="accent4" accent5="accent5" accent6="accent6" hlink="hlink" folHlink="folHlink"/>
   <p:sldLayoutIdLst>
-    <p:sldLayoutId xmlns:r="http://schemas.openxmlformats.org/officeDocument/2006/relationships" id="2147483649" r:id="Rdf08202a86b54cec"/>
+    <p:sldLayoutId xmlns:r="http://schemas.openxmlformats.org/officeDocument/2006/relationships" id="2147483649" r:id="R29a639b1f2ea4b5a"/>
   </p:sldLayoutIdLst>
   <p:txStyles>
     <p:titleStyle>
@@ -1490,14 +1500,14 @@
       </p:grpSpPr>
       <p:pic>
         <p:nvPicPr>
-          <p:cNvPr id="87" name=""/>
+          <p:cNvPr id="180" name=""/>
           <p:cNvPicPr>
             <a:picLocks xmlns:a="http://schemas.openxmlformats.org/drawingml/2006/main" noChangeAspect="1"/>
           </p:cNvPicPr>
           <p:nvPr/>
         </p:nvPicPr>
         <p:blipFill>
-          <a:blip xmlns:r="http://schemas.openxmlformats.org/officeDocument/2006/relationships" xmlns:a="http://schemas.openxmlformats.org/drawingml/2006/main" r:embed="R9bb9096f725d41f6"/>
+          <a:blip xmlns:r="http://schemas.openxmlformats.org/officeDocument/2006/relationships" xmlns:a="http://schemas.openxmlformats.org/drawingml/2006/main" r:embed="R3214d42bc2394fed"/>
           <a:srcRect xmlns:a="http://schemas.openxmlformats.org/drawingml/2006/main" l="0" t="27" r="0" b="27"/>
           <a:stretch xmlns:a="http://schemas.openxmlformats.org/drawingml/2006/main">
             <a:fillRect l="0" t="0" r="0" b="0"/>
@@ -1513,52 +1523,24 @@
           </a:prstGeom>
         </p:spPr>
       </p:pic>
-      <p:pic>
-        <p:nvPicPr>
-          <p:cNvPr id="88" name=""/>
-          <p:cNvPicPr>
-            <a:picLocks xmlns:a="http://schemas.openxmlformats.org/drawingml/2006/main" noChangeAspect="1"/>
-          </p:cNvPicPr>
-          <p:nvPr/>
-        </p:nvPicPr>
-        <p:blipFill>
-          <a:blip xmlns:r="http://schemas.openxmlformats.org/officeDocument/2006/relationships" xmlns:a="http://schemas.openxmlformats.org/drawingml/2006/main" r:embed="R9bb9096f725d41f6">
-            <a:extLst>
-              <a:ext uri="{96DAC541-7B7A-43D3-8B79-37D633B846F1}">
-                <asvg:svgBlip xmlns:asvg="http://schemas.microsoft.com/office/drawing/2016/SVG/main" r:embed="R04dd5d151c2e44c1"/>
-              </a:ext>
-            </a:extLst>
-          </a:blip>
-          <a:stretch xmlns:a="http://schemas.openxmlformats.org/drawingml/2006/main"/>
-        </p:blipFill>
-        <p:spPr>
-          <a:xfrm xmlns:a="http://schemas.openxmlformats.org/drawingml/2006/main">
-            <a:off x="476250" y="400050"/>
-            <a:ext cx="381000" cy="381000"/>
-          </a:xfrm>
-          <a:prstGeom xmlns:a="http://schemas.openxmlformats.org/drawingml/2006/main" prst="rect">
-            <a:avLst/>
-          </a:prstGeom>
-        </p:spPr>
-      </p:pic>
-      <p:sp>
-        <p:nvSpPr>
-          <p:cNvPr id="3" name="">
-            <a:extLst xmlns:a="http://schemas.openxmlformats.org/drawingml/2006/main">
-              <a:ext uri="{FF2B5EF4-FFF2-40B4-BE49-F238E27FC236}">
-                <a16:creationId xmlns:a16="http://schemas.microsoft.com/office/drawing/2014/main" id="{4FC1FF57-87B5-4009-9D1B-1C4C2D1ECBFC}"/>
-              </a:ext>
-            </a:extLst>
-          </p:cNvPr>
-          <p:cNvSpPr>
-            <a:spLocks xmlns:a="http://schemas.openxmlformats.org/drawingml/2006/main" noGrp="1"/>
-          </p:cNvSpPr>
-          <p:nvPr/>
-        </p:nvSpPr>
-        <p:spPr>
-          <a:xfrm xmlns:a="http://schemas.openxmlformats.org/drawingml/2006/main">
-            <a:off x="962025" y="438150"/>
-            <a:ext cx="971550" cy="285750"/>
+      <p:sp>
+        <p:nvSpPr>
+          <p:cNvPr id="5" name="">
+            <a:extLst xmlns:a="http://schemas.openxmlformats.org/drawingml/2006/main">
+              <a:ext uri="{FF2B5EF4-FFF2-40B4-BE49-F238E27FC236}">
+                <a16:creationId xmlns:a16="http://schemas.microsoft.com/office/drawing/2014/main" id="{59DEA8B0-72D6-410E-B576-225492906D2D}"/>
+              </a:ext>
+            </a:extLst>
+          </p:cNvPr>
+          <p:cNvSpPr>
+            <a:spLocks xmlns:a="http://schemas.openxmlformats.org/drawingml/2006/main" noGrp="1"/>
+          </p:cNvSpPr>
+          <p:nvPr/>
+        </p:nvSpPr>
+        <p:spPr>
+          <a:xfrm xmlns:a="http://schemas.openxmlformats.org/drawingml/2006/main">
+            <a:off x="495300" y="1219200"/>
+            <a:ext cx="4762500" cy="228600"/>
           </a:xfrm>
           <a:prstGeom xmlns:a="http://schemas.openxmlformats.org/drawingml/2006/main" prst="rect">
             <a:avLst/>
@@ -1577,7 +1559,66 @@
           <a:p xmlns:a="http://schemas.openxmlformats.org/drawingml/2006/main">
             <a:pPr algn="l">
               <a:buNone/>
-              <a:defRPr sz="1650" b="1">
+              <a:defRPr sz="1050" b="1">
+                <a:solidFill>
+                  <a:srgbClr val="6CF8BB"/>
+                </a:solidFill>
+                <a:latin typeface="Helvetica Neue"/>
+                <a:ea typeface="Helvetica Neue"/>
+                <a:cs typeface="Helvetica Neue"/>
+              </a:defRPr>
+            </a:pPr>
+            <a:r>
+              <a:rPr sz="1050" b="1">
+                <a:solidFill>
+                  <a:srgbClr val="6CF8BB"/>
+                </a:solidFill>
+                <a:latin typeface="Helvetica Neue"/>
+                <a:ea typeface="Helvetica Neue"/>
+                <a:cs typeface="Helvetica Neue"/>
+              </a:rPr>
+              <a:t>THE AI OPERATING SYSTEM FOR INDIA'S HARDWARE TRADE</a:t>
+            </a:r>
+          </a:p>
+        </p:txBody>
+      </p:sp>
+      <p:sp>
+        <p:nvSpPr>
+          <p:cNvPr id="6" name="">
+            <a:extLst xmlns:a="http://schemas.openxmlformats.org/drawingml/2006/main">
+              <a:ext uri="{FF2B5EF4-FFF2-40B4-BE49-F238E27FC236}">
+                <a16:creationId xmlns:a16="http://schemas.microsoft.com/office/drawing/2014/main" id="{D0527617-5FF0-4C96-8104-C820629C79D8}"/>
+              </a:ext>
+            </a:extLst>
+          </p:cNvPr>
+          <p:cNvSpPr>
+            <a:spLocks xmlns:a="http://schemas.openxmlformats.org/drawingml/2006/main" noGrp="1"/>
+          </p:cNvSpPr>
+          <p:nvPr/>
+        </p:nvSpPr>
+        <p:spPr>
+          <a:xfrm xmlns:a="http://schemas.openxmlformats.org/drawingml/2006/main">
+            <a:off x="476250" y="1752600"/>
+            <a:ext cx="5334000" cy="704850"/>
+          </a:xfrm>
+          <a:prstGeom xmlns:a="http://schemas.openxmlformats.org/drawingml/2006/main" prst="rect">
+            <a:avLst/>
+          </a:prstGeom>
+          <a:noFill xmlns:a="http://schemas.openxmlformats.org/drawingml/2006/main"/>
+          <a:ln xmlns:a="http://schemas.openxmlformats.org/drawingml/2006/main" w="0">
+            <a:noFill/>
+            <a:prstDash val="solid"/>
+          </a:ln>
+        </p:spPr>
+        <p:txBody>
+          <a:bodyPr xmlns:a="http://schemas.openxmlformats.org/drawingml/2006/main" wrap="square" lIns="0" tIns="0" rIns="0" bIns="0" anchor="t">
+            <a:normAutofit fontScale="99462"/>
+          </a:bodyPr>
+          <a:lstStyle xmlns:a="http://schemas.openxmlformats.org/drawingml/2006/main"/>
+          <a:p xmlns:a="http://schemas.openxmlformats.org/drawingml/2006/main">
+            <a:pPr algn="l">
+              <a:buNone/>
+              <a:defRPr sz="4650" b="1">
                 <a:solidFill>
                   <a:srgbClr val="F7FAF8"/>
                 </a:solidFill>
@@ -1587,7 +1628,7 @@
               </a:defRPr>
             </a:pPr>
             <a:r>
-              <a:rPr sz="1650" b="1">
+              <a:rPr sz="4650" b="1">
                 <a:solidFill>
                   <a:srgbClr val="F7FAF8"/>
                 </a:solidFill>
@@ -1595,29 +1636,88 @@
                 <a:ea typeface="Helvetica Neue"/>
                 <a:cs typeface="Helvetica Neue"/>
               </a:rPr>
-              <a:t>Chhotu</a:t>
-            </a:r>
-          </a:p>
-        </p:txBody>
-      </p:sp>
-      <p:sp>
-        <p:nvSpPr>
-          <p:cNvPr id="4" name="">
-            <a:extLst xmlns:a="http://schemas.openxmlformats.org/drawingml/2006/main">
-              <a:ext uri="{FF2B5EF4-FFF2-40B4-BE49-F238E27FC236}">
-                <a16:creationId xmlns:a16="http://schemas.microsoft.com/office/drawing/2014/main" id="{5ADC2DAD-97E9-4DD4-910A-383FB54CC987}"/>
-              </a:ext>
-            </a:extLst>
-          </p:cNvPr>
-          <p:cNvSpPr>
-            <a:spLocks xmlns:a="http://schemas.openxmlformats.org/drawingml/2006/main" noGrp="1"/>
-          </p:cNvSpPr>
-          <p:nvPr/>
-        </p:nvSpPr>
-        <p:spPr>
-          <a:xfrm xmlns:a="http://schemas.openxmlformats.org/drawingml/2006/main">
-            <a:off x="1809750" y="438150"/>
-            <a:ext cx="476250" cy="285750"/>
+              <a:t>Your business</a:t>
+            </a:r>
+          </a:p>
+        </p:txBody>
+      </p:sp>
+      <p:sp>
+        <p:nvSpPr>
+          <p:cNvPr id="7" name="">
+            <a:extLst xmlns:a="http://schemas.openxmlformats.org/drawingml/2006/main">
+              <a:ext uri="{FF2B5EF4-FFF2-40B4-BE49-F238E27FC236}">
+                <a16:creationId xmlns:a16="http://schemas.microsoft.com/office/drawing/2014/main" id="{28E3960B-5776-476E-A941-039263333FCC}"/>
+              </a:ext>
+            </a:extLst>
+          </p:cNvPr>
+          <p:cNvSpPr>
+            <a:spLocks xmlns:a="http://schemas.openxmlformats.org/drawingml/2006/main" noGrp="1"/>
+          </p:cNvSpPr>
+          <p:nvPr/>
+        </p:nvSpPr>
+        <p:spPr>
+          <a:xfrm xmlns:a="http://schemas.openxmlformats.org/drawingml/2006/main">
+            <a:off x="476250" y="2447925"/>
+            <a:ext cx="5334000" cy="704850"/>
+          </a:xfrm>
+          <a:prstGeom xmlns:a="http://schemas.openxmlformats.org/drawingml/2006/main" prst="rect">
+            <a:avLst/>
+          </a:prstGeom>
+          <a:noFill xmlns:a="http://schemas.openxmlformats.org/drawingml/2006/main"/>
+          <a:ln xmlns:a="http://schemas.openxmlformats.org/drawingml/2006/main" w="0">
+            <a:noFill/>
+            <a:prstDash val="solid"/>
+          </a:ln>
+        </p:spPr>
+        <p:txBody>
+          <a:bodyPr xmlns:a="http://schemas.openxmlformats.org/drawingml/2006/main" wrap="square" lIns="0" tIns="0" rIns="0" bIns="0" anchor="t">
+            <a:normAutofit fontScale="99462"/>
+          </a:bodyPr>
+          <a:lstStyle xmlns:a="http://schemas.openxmlformats.org/drawingml/2006/main"/>
+          <a:p xmlns:a="http://schemas.openxmlformats.org/drawingml/2006/main">
+            <a:pPr algn="l">
+              <a:buNone/>
+              <a:defRPr sz="4650" b="1">
+                <a:solidFill>
+                  <a:srgbClr val="79827D"/>
+                </a:solidFill>
+                <a:latin typeface="Helvetica Neue"/>
+                <a:ea typeface="Helvetica Neue"/>
+                <a:cs typeface="Helvetica Neue"/>
+              </a:defRPr>
+            </a:pPr>
+            <a:r>
+              <a:rPr sz="4650" b="1">
+                <a:solidFill>
+                  <a:srgbClr val="79827D"/>
+                </a:solidFill>
+                <a:latin typeface="Helvetica Neue"/>
+                <a:ea typeface="Helvetica Neue"/>
+                <a:cs typeface="Helvetica Neue"/>
+              </a:rPr>
+              <a:t>just learned</a:t>
+            </a:r>
+          </a:p>
+        </p:txBody>
+      </p:sp>
+      <p:sp>
+        <p:nvSpPr>
+          <p:cNvPr id="8" name="">
+            <a:extLst xmlns:a="http://schemas.openxmlformats.org/drawingml/2006/main">
+              <a:ext uri="{FF2B5EF4-FFF2-40B4-BE49-F238E27FC236}">
+                <a16:creationId xmlns:a16="http://schemas.microsoft.com/office/drawing/2014/main" id="{17946C83-2036-49E8-887B-D06697640A51}"/>
+              </a:ext>
+            </a:extLst>
+          </p:cNvPr>
+          <p:cNvSpPr>
+            <a:spLocks xmlns:a="http://schemas.openxmlformats.org/drawingml/2006/main" noGrp="1"/>
+          </p:cNvSpPr>
+          <p:nvPr/>
+        </p:nvSpPr>
+        <p:spPr>
+          <a:xfrm xmlns:a="http://schemas.openxmlformats.org/drawingml/2006/main">
+            <a:off x="476250" y="3143250"/>
+            <a:ext cx="4762500" cy="781050"/>
           </a:xfrm>
           <a:prstGeom xmlns:a="http://schemas.openxmlformats.org/drawingml/2006/main" prst="rect">
             <a:avLst/>
@@ -1636,7 +1736,7 @@
           <a:p xmlns:a="http://schemas.openxmlformats.org/drawingml/2006/main">
             <a:pPr algn="l">
               <a:buNone/>
-              <a:defRPr sz="1650" b="1">
+              <a:defRPr sz="5100" b="1">
                 <a:solidFill>
                   <a:srgbClr val="6CF8BB"/>
                 </a:solidFill>
@@ -1646,7 +1746,7 @@
               </a:defRPr>
             </a:pPr>
             <a:r>
-              <a:rPr sz="1650" b="1">
+              <a:rPr sz="5100" b="1">
                 <a:solidFill>
                   <a:srgbClr val="6CF8BB"/>
                 </a:solidFill>
@@ -1654,29 +1754,29 @@
                 <a:ea typeface="Helvetica Neue"/>
                 <a:cs typeface="Helvetica Neue"/>
               </a:rPr>
-              <a:t>.ai</a:t>
-            </a:r>
-          </a:p>
-        </p:txBody>
-      </p:sp>
-      <p:sp>
-        <p:nvSpPr>
-          <p:cNvPr id="5" name="">
-            <a:extLst xmlns:a="http://schemas.openxmlformats.org/drawingml/2006/main">
-              <a:ext uri="{FF2B5EF4-FFF2-40B4-BE49-F238E27FC236}">
-                <a16:creationId xmlns:a16="http://schemas.microsoft.com/office/drawing/2014/main" id="{59DEA8B0-72D6-410E-B576-225492906D2D}"/>
-              </a:ext>
-            </a:extLst>
-          </p:cNvPr>
-          <p:cNvSpPr>
-            <a:spLocks xmlns:a="http://schemas.openxmlformats.org/drawingml/2006/main" noGrp="1"/>
-          </p:cNvSpPr>
-          <p:nvPr/>
-        </p:nvSpPr>
-        <p:spPr>
-          <a:xfrm xmlns:a="http://schemas.openxmlformats.org/drawingml/2006/main">
-            <a:off x="495300" y="1219200"/>
-            <a:ext cx="4762500" cy="228600"/>
+              <a:t>to listen.</a:t>
+            </a:r>
+          </a:p>
+        </p:txBody>
+      </p:sp>
+      <p:sp>
+        <p:nvSpPr>
+          <p:cNvPr id="9" name="">
+            <a:extLst xmlns:a="http://schemas.openxmlformats.org/drawingml/2006/main">
+              <a:ext uri="{FF2B5EF4-FFF2-40B4-BE49-F238E27FC236}">
+                <a16:creationId xmlns:a16="http://schemas.microsoft.com/office/drawing/2014/main" id="{C1F654FB-E953-4731-81C9-BFCE75A8CCD8}"/>
+              </a:ext>
+            </a:extLst>
+          </p:cNvPr>
+          <p:cNvSpPr>
+            <a:spLocks xmlns:a="http://schemas.openxmlformats.org/drawingml/2006/main" noGrp="1"/>
+          </p:cNvSpPr>
+          <p:nvPr/>
+        </p:nvSpPr>
+        <p:spPr>
+          <a:xfrm xmlns:a="http://schemas.openxmlformats.org/drawingml/2006/main">
+            <a:off x="504825" y="4095750"/>
+            <a:ext cx="4953000" cy="609600"/>
           </a:xfrm>
           <a:prstGeom xmlns:a="http://schemas.openxmlformats.org/drawingml/2006/main" prst="rect">
             <a:avLst/>
@@ -1695,242 +1795,6 @@
           <a:p xmlns:a="http://schemas.openxmlformats.org/drawingml/2006/main">
             <a:pPr algn="l">
               <a:buNone/>
-              <a:defRPr sz="1050" b="1">
-                <a:solidFill>
-                  <a:srgbClr val="6CF8BB"/>
-                </a:solidFill>
-                <a:latin typeface="Helvetica Neue"/>
-                <a:ea typeface="Helvetica Neue"/>
-                <a:cs typeface="Helvetica Neue"/>
-              </a:defRPr>
-            </a:pPr>
-            <a:r>
-              <a:rPr sz="1050" b="1">
-                <a:solidFill>
-                  <a:srgbClr val="6CF8BB"/>
-                </a:solidFill>
-                <a:latin typeface="Helvetica Neue"/>
-                <a:ea typeface="Helvetica Neue"/>
-                <a:cs typeface="Helvetica Neue"/>
-              </a:rPr>
-              <a:t>THE OPERATING SYSTEM FOR HARDWARE &amp; CONSTRUCTION TRADE</a:t>
-            </a:r>
-          </a:p>
-        </p:txBody>
-      </p:sp>
-      <p:sp>
-        <p:nvSpPr>
-          <p:cNvPr id="6" name="">
-            <a:extLst xmlns:a="http://schemas.openxmlformats.org/drawingml/2006/main">
-              <a:ext uri="{FF2B5EF4-FFF2-40B4-BE49-F238E27FC236}">
-                <a16:creationId xmlns:a16="http://schemas.microsoft.com/office/drawing/2014/main" id="{D0527617-5FF0-4C96-8104-C820629C79D8}"/>
-              </a:ext>
-            </a:extLst>
-          </p:cNvPr>
-          <p:cNvSpPr>
-            <a:spLocks xmlns:a="http://schemas.openxmlformats.org/drawingml/2006/main" noGrp="1"/>
-          </p:cNvSpPr>
-          <p:nvPr/>
-        </p:nvSpPr>
-        <p:spPr>
-          <a:xfrm xmlns:a="http://schemas.openxmlformats.org/drawingml/2006/main">
-            <a:off x="476250" y="1695450"/>
-            <a:ext cx="5810250" cy="704850"/>
-          </a:xfrm>
-          <a:prstGeom xmlns:a="http://schemas.openxmlformats.org/drawingml/2006/main" prst="rect">
-            <a:avLst/>
-          </a:prstGeom>
-          <a:noFill xmlns:a="http://schemas.openxmlformats.org/drawingml/2006/main"/>
-          <a:ln xmlns:a="http://schemas.openxmlformats.org/drawingml/2006/main" w="0">
-            <a:noFill/>
-            <a:prstDash val="solid"/>
-          </a:ln>
-        </p:spPr>
-        <p:txBody>
-          <a:bodyPr xmlns:a="http://schemas.openxmlformats.org/drawingml/2006/main" wrap="square" lIns="0" tIns="0" rIns="0" bIns="0" anchor="t">
-            <a:normAutofit fontScale="86023"/>
-          </a:bodyPr>
-          <a:lstStyle xmlns:a="http://schemas.openxmlformats.org/drawingml/2006/main"/>
-          <a:p xmlns:a="http://schemas.openxmlformats.org/drawingml/2006/main">
-            <a:pPr algn="l">
-              <a:buNone/>
-              <a:defRPr sz="4650" b="1">
-                <a:solidFill>
-                  <a:srgbClr val="F7FAF8"/>
-                </a:solidFill>
-                <a:latin typeface="Helvetica Neue"/>
-                <a:ea typeface="Helvetica Neue"/>
-                <a:cs typeface="Helvetica Neue"/>
-              </a:defRPr>
-            </a:pPr>
-            <a:r>
-              <a:rPr sz="4650" b="1">
-                <a:solidFill>
-                  <a:srgbClr val="F7FAF8"/>
-                </a:solidFill>
-                <a:latin typeface="Helvetica Neue"/>
-                <a:ea typeface="Helvetica Neue"/>
-                <a:cs typeface="Helvetica Neue"/>
-              </a:rPr>
-              <a:t>Your hardware business</a:t>
-            </a:r>
-          </a:p>
-        </p:txBody>
-      </p:sp>
-      <p:sp>
-        <p:nvSpPr>
-          <p:cNvPr id="7" name="">
-            <a:extLst xmlns:a="http://schemas.openxmlformats.org/drawingml/2006/main">
-              <a:ext uri="{FF2B5EF4-FFF2-40B4-BE49-F238E27FC236}">
-                <a16:creationId xmlns:a16="http://schemas.microsoft.com/office/drawing/2014/main" id="{28E3960B-5776-476E-A941-039263333FCC}"/>
-              </a:ext>
-            </a:extLst>
-          </p:cNvPr>
-          <p:cNvSpPr>
-            <a:spLocks xmlns:a="http://schemas.openxmlformats.org/drawingml/2006/main" noGrp="1"/>
-          </p:cNvSpPr>
-          <p:nvPr/>
-        </p:nvSpPr>
-        <p:spPr>
-          <a:xfrm xmlns:a="http://schemas.openxmlformats.org/drawingml/2006/main">
-            <a:off x="476250" y="2390775"/>
-            <a:ext cx="5810250" cy="704850"/>
-          </a:xfrm>
-          <a:prstGeom xmlns:a="http://schemas.openxmlformats.org/drawingml/2006/main" prst="rect">
-            <a:avLst/>
-          </a:prstGeom>
-          <a:noFill xmlns:a="http://schemas.openxmlformats.org/drawingml/2006/main"/>
-          <a:ln xmlns:a="http://schemas.openxmlformats.org/drawingml/2006/main" w="0">
-            <a:noFill/>
-            <a:prstDash val="solid"/>
-          </a:ln>
-        </p:spPr>
-        <p:txBody>
-          <a:bodyPr xmlns:a="http://schemas.openxmlformats.org/drawingml/2006/main" wrap="square" lIns="0" tIns="0" rIns="0" bIns="0" anchor="t">
-            <a:normAutofit fontScale="99462"/>
-          </a:bodyPr>
-          <a:lstStyle xmlns:a="http://schemas.openxmlformats.org/drawingml/2006/main"/>
-          <a:p xmlns:a="http://schemas.openxmlformats.org/drawingml/2006/main">
-            <a:pPr algn="l">
-              <a:buNone/>
-              <a:defRPr sz="4650" b="1">
-                <a:solidFill>
-                  <a:srgbClr val="79827D"/>
-                </a:solidFill>
-                <a:latin typeface="Helvetica Neue"/>
-                <a:ea typeface="Helvetica Neue"/>
-                <a:cs typeface="Helvetica Neue"/>
-              </a:defRPr>
-            </a:pPr>
-            <a:r>
-              <a:rPr sz="4650" b="1">
-                <a:solidFill>
-                  <a:srgbClr val="79827D"/>
-                </a:solidFill>
-                <a:latin typeface="Helvetica Neue"/>
-                <a:ea typeface="Helvetica Neue"/>
-                <a:cs typeface="Helvetica Neue"/>
-              </a:rPr>
-              <a:t>just learned</a:t>
-            </a:r>
-          </a:p>
-        </p:txBody>
-      </p:sp>
-      <p:sp>
-        <p:nvSpPr>
-          <p:cNvPr id="8" name="">
-            <a:extLst xmlns:a="http://schemas.openxmlformats.org/drawingml/2006/main">
-              <a:ext uri="{FF2B5EF4-FFF2-40B4-BE49-F238E27FC236}">
-                <a16:creationId xmlns:a16="http://schemas.microsoft.com/office/drawing/2014/main" id="{17946C83-2036-49E8-887B-D06697640A51}"/>
-              </a:ext>
-            </a:extLst>
-          </p:cNvPr>
-          <p:cNvSpPr>
-            <a:spLocks xmlns:a="http://schemas.openxmlformats.org/drawingml/2006/main" noGrp="1"/>
-          </p:cNvSpPr>
-          <p:nvPr/>
-        </p:nvSpPr>
-        <p:spPr>
-          <a:xfrm xmlns:a="http://schemas.openxmlformats.org/drawingml/2006/main">
-            <a:off x="476250" y="3086100"/>
-            <a:ext cx="4762500" cy="781050"/>
-          </a:xfrm>
-          <a:prstGeom xmlns:a="http://schemas.openxmlformats.org/drawingml/2006/main" prst="rect">
-            <a:avLst/>
-          </a:prstGeom>
-          <a:noFill xmlns:a="http://schemas.openxmlformats.org/drawingml/2006/main"/>
-          <a:ln xmlns:a="http://schemas.openxmlformats.org/drawingml/2006/main" w="0">
-            <a:noFill/>
-            <a:prstDash val="solid"/>
-          </a:ln>
-        </p:spPr>
-        <p:txBody>
-          <a:bodyPr xmlns:a="http://schemas.openxmlformats.org/drawingml/2006/main" wrap="square" lIns="0" tIns="0" rIns="0" bIns="0" anchor="t">
-            <a:normAutofit fontScale="100000"/>
-          </a:bodyPr>
-          <a:lstStyle xmlns:a="http://schemas.openxmlformats.org/drawingml/2006/main"/>
-          <a:p xmlns:a="http://schemas.openxmlformats.org/drawingml/2006/main">
-            <a:pPr algn="l">
-              <a:buNone/>
-              <a:defRPr sz="5100" b="1">
-                <a:solidFill>
-                  <a:srgbClr val="6CF8BB"/>
-                </a:solidFill>
-                <a:latin typeface="Helvetica Neue"/>
-                <a:ea typeface="Helvetica Neue"/>
-                <a:cs typeface="Helvetica Neue"/>
-              </a:defRPr>
-            </a:pPr>
-            <a:r>
-              <a:rPr sz="5100" b="1">
-                <a:solidFill>
-                  <a:srgbClr val="6CF8BB"/>
-                </a:solidFill>
-                <a:latin typeface="Helvetica Neue"/>
-                <a:ea typeface="Helvetica Neue"/>
-                <a:cs typeface="Helvetica Neue"/>
-              </a:rPr>
-              <a:t>to listen.</a:t>
-            </a:r>
-          </a:p>
-        </p:txBody>
-      </p:sp>
-      <p:sp>
-        <p:nvSpPr>
-          <p:cNvPr id="9" name="">
-            <a:extLst xmlns:a="http://schemas.openxmlformats.org/drawingml/2006/main">
-              <a:ext uri="{FF2B5EF4-FFF2-40B4-BE49-F238E27FC236}">
-                <a16:creationId xmlns:a16="http://schemas.microsoft.com/office/drawing/2014/main" id="{C1F654FB-E953-4731-81C9-BFCE75A8CCD8}"/>
-              </a:ext>
-            </a:extLst>
-          </p:cNvPr>
-          <p:cNvSpPr>
-            <a:spLocks xmlns:a="http://schemas.openxmlformats.org/drawingml/2006/main" noGrp="1"/>
-          </p:cNvSpPr>
-          <p:nvPr/>
-        </p:nvSpPr>
-        <p:spPr>
-          <a:xfrm xmlns:a="http://schemas.openxmlformats.org/drawingml/2006/main">
-            <a:off x="504825" y="4114800"/>
-            <a:ext cx="5191125" cy="666750"/>
-          </a:xfrm>
-          <a:prstGeom xmlns:a="http://schemas.openxmlformats.org/drawingml/2006/main" prst="rect">
-            <a:avLst/>
-          </a:prstGeom>
-          <a:noFill xmlns:a="http://schemas.openxmlformats.org/drawingml/2006/main"/>
-          <a:ln xmlns:a="http://schemas.openxmlformats.org/drawingml/2006/main" w="0">
-            <a:noFill/>
-            <a:prstDash val="solid"/>
-          </a:ln>
-        </p:spPr>
-        <p:txBody>
-          <a:bodyPr xmlns:a="http://schemas.openxmlformats.org/drawingml/2006/main" wrap="square" lIns="0" tIns="0" rIns="0" bIns="0" anchor="t">
-            <a:normAutofit fontScale="100000"/>
-          </a:bodyPr>
-          <a:lstStyle xmlns:a="http://schemas.openxmlformats.org/drawingml/2006/main"/>
-          <a:p xmlns:a="http://schemas.openxmlformats.org/drawingml/2006/main">
-            <a:pPr algn="l">
-              <a:buNone/>
               <a:defRPr sz="1575" b="0">
                 <a:solidFill>
                   <a:srgbClr val="9CA59F"/>
@@ -1949,14 +1813,14 @@
                 <a:ea typeface="Helvetica Neue"/>
                 <a:cs typeface="Helvetica Neue"/>
               </a:rPr>
-              <a:t>Voice-first operations for hardware and construction retailers, wholesalers and distributors.</a:t>
+              <a:t>Voice-first operations for hardware retailers, wholesalers and distributors.</a:t>
             </a:r>
           </a:p>
         </p:txBody>
       </p:sp>
       <p:cxnSp>
         <p:nvCxnSpPr>
-          <p:cNvPr id="96" name=""/>
+          <p:cNvPr id="186" name=""/>
           <p:cNvCxnSpPr/>
           <p:nvPr/>
         </p:nvCxnSpPr>
@@ -2208,6 +2072,114 @@
                 <a:cs typeface="Helvetica Neue"/>
               </a:rPr>
               <a:t>INVESTOR / JURY PITCH</a:t>
+            </a:r>
+          </a:p>
+        </p:txBody>
+      </p:sp>
+      <p:pic>
+        <p:nvPicPr>
+          <p:cNvPr id="191" name=""/>
+          <p:cNvPicPr>
+            <a:picLocks xmlns:a="http://schemas.openxmlformats.org/drawingml/2006/main" noChangeAspect="1"/>
+          </p:cNvPicPr>
+          <p:nvPr/>
+        </p:nvPicPr>
+        <p:blipFill>
+          <a:blip xmlns:r="http://schemas.openxmlformats.org/officeDocument/2006/relationships" xmlns:a="http://schemas.openxmlformats.org/drawingml/2006/main" r:embed="Rac2fa249a5f24c5b"/>
+          <a:stretch xmlns:a="http://schemas.openxmlformats.org/drawingml/2006/main"/>
+        </p:blipFill>
+        <p:spPr>
+          <a:xfrm xmlns:a="http://schemas.openxmlformats.org/drawingml/2006/main">
+            <a:off x="476250" y="342900"/>
+            <a:ext cx="266700" cy="266700"/>
+          </a:xfrm>
+          <a:prstGeom xmlns:a="http://schemas.openxmlformats.org/drawingml/2006/main" prst="rect">
+            <a:avLst/>
+          </a:prstGeom>
+        </p:spPr>
+      </p:pic>
+      <p:pic>
+        <p:nvPicPr>
+          <p:cNvPr id="192" name=""/>
+          <p:cNvPicPr>
+            <a:picLocks xmlns:a="http://schemas.openxmlformats.org/drawingml/2006/main" noChangeAspect="1"/>
+          </p:cNvPicPr>
+          <p:nvPr/>
+        </p:nvPicPr>
+        <p:blipFill>
+          <a:blip xmlns:r="http://schemas.openxmlformats.org/officeDocument/2006/relationships" xmlns:a="http://schemas.openxmlformats.org/drawingml/2006/main" r:embed="Rc96ca138cafe4b66"/>
+          <a:stretch xmlns:a="http://schemas.openxmlformats.org/drawingml/2006/main"/>
+        </p:blipFill>
+        <p:spPr>
+          <a:xfrm xmlns:a="http://schemas.openxmlformats.org/drawingml/2006/main">
+            <a:off x="476250" y="342900"/>
+            <a:ext cx="266700" cy="266700"/>
+          </a:xfrm>
+          <a:prstGeom xmlns:a="http://schemas.openxmlformats.org/drawingml/2006/main" prst="rect">
+            <a:avLst/>
+          </a:prstGeom>
+        </p:spPr>
+      </p:pic>
+      <p:sp>
+        <p:nvSpPr>
+          <p:cNvPr id="179" name="Chhotu.ai wordmark">
+            <a:extLst xmlns:a="http://schemas.openxmlformats.org/drawingml/2006/main">
+              <a:ext uri="{FF2B5EF4-FFF2-40B4-BE49-F238E27FC236}">
+                <a16:creationId xmlns:a16="http://schemas.microsoft.com/office/drawing/2014/main" id="{445CBE6C-9076-4D4F-90A6-061AB05FA3D7}"/>
+              </a:ext>
+            </a:extLst>
+          </p:cNvPr>
+          <p:cNvSpPr>
+            <a:spLocks xmlns:a="http://schemas.openxmlformats.org/drawingml/2006/main" noGrp="1"/>
+          </p:cNvSpPr>
+          <p:nvPr/>
+        </p:nvSpPr>
+        <p:spPr>
+          <a:xfrm xmlns:a="http://schemas.openxmlformats.org/drawingml/2006/main">
+            <a:off x="800100" y="314325"/>
+            <a:ext cx="1066800" cy="323850"/>
+          </a:xfrm>
+          <a:prstGeom xmlns:a="http://schemas.openxmlformats.org/drawingml/2006/main" prst="rect">
+            <a:avLst/>
+          </a:prstGeom>
+          <a:noFill xmlns:a="http://schemas.openxmlformats.org/drawingml/2006/main"/>
+          <a:ln xmlns:a="http://schemas.openxmlformats.org/drawingml/2006/main" w="0">
+            <a:noFill/>
+            <a:prstDash val="solid"/>
+          </a:ln>
+        </p:spPr>
+        <p:txBody>
+          <a:bodyPr xmlns:a="http://schemas.openxmlformats.org/drawingml/2006/main" anchor="ctr"/>
+          <a:lstStyle xmlns:a="http://schemas.openxmlformats.org/drawingml/2006/main"/>
+          <a:p xmlns:a="http://schemas.openxmlformats.org/drawingml/2006/main">
+            <a:pPr>
+              <a:defRPr sz="1500">
+                <a:latin typeface="Arial"/>
+                <a:ea typeface="Arial"/>
+                <a:cs typeface="Arial"/>
+              </a:defRPr>
+            </a:pPr>
+            <a:r>
+              <a:rPr sz="1500" b="1">
+                <a:solidFill>
+                  <a:srgbClr val="F7F8F8"/>
+                </a:solidFill>
+                <a:latin typeface="Arial"/>
+                <a:ea typeface="Arial"/>
+                <a:cs typeface="Arial"/>
+              </a:rPr>
+              <a:t>Chhotu</a:t>
+            </a:r>
+            <a:r>
+              <a:rPr sz="1500" b="1">
+                <a:solidFill>
+                  <a:srgbClr val="59F2BC"/>
+                </a:solidFill>
+                <a:latin typeface="Arial"/>
+                <a:ea typeface="Arial"/>
+                <a:cs typeface="Arial"/>
+              </a:rPr>
+              <a:t>.ai</a:t>
             </a:r>
           </a:p>
         </p:txBody>
@@ -2241,52 +2213,24 @@
       <p:grpSpPr>
         <a:xfrm xmlns:a="http://schemas.openxmlformats.org/drawingml/2006/main"/>
       </p:grpSpPr>
-      <p:pic>
-        <p:nvPicPr>
-          <p:cNvPr id="95" name=""/>
-          <p:cNvPicPr>
-            <a:picLocks xmlns:a="http://schemas.openxmlformats.org/drawingml/2006/main" noChangeAspect="1"/>
-          </p:cNvPicPr>
-          <p:nvPr/>
-        </p:nvPicPr>
-        <p:blipFill>
-          <a:blip xmlns:r="http://schemas.openxmlformats.org/officeDocument/2006/relationships" xmlns:a="http://schemas.openxmlformats.org/drawingml/2006/main" r:embed="R12065bf9842745ce">
-            <a:extLst>
-              <a:ext uri="{96DAC541-7B7A-43D3-8B79-37D633B846F1}">
-                <asvg:svgBlip xmlns:asvg="http://schemas.microsoft.com/office/drawing/2016/SVG/main" r:embed="R510b723ddf9d4460"/>
-              </a:ext>
-            </a:extLst>
-          </a:blip>
-          <a:stretch xmlns:a="http://schemas.openxmlformats.org/drawingml/2006/main"/>
-        </p:blipFill>
-        <p:spPr>
-          <a:xfrm xmlns:a="http://schemas.openxmlformats.org/drawingml/2006/main">
-            <a:off x="476250" y="400050"/>
-            <a:ext cx="381000" cy="381000"/>
-          </a:xfrm>
-          <a:prstGeom xmlns:a="http://schemas.openxmlformats.org/drawingml/2006/main" prst="rect">
-            <a:avLst/>
-          </a:prstGeom>
-        </p:spPr>
-      </p:pic>
-      <p:sp>
-        <p:nvSpPr>
-          <p:cNvPr id="2" name="">
-            <a:extLst xmlns:a="http://schemas.openxmlformats.org/drawingml/2006/main">
-              <a:ext uri="{FF2B5EF4-FFF2-40B4-BE49-F238E27FC236}">
-                <a16:creationId xmlns:a16="http://schemas.microsoft.com/office/drawing/2014/main" id="{1FDC1CB2-37D6-45EF-AFD2-B99CC737F3D8}"/>
-              </a:ext>
-            </a:extLst>
-          </p:cNvPr>
-          <p:cNvSpPr>
-            <a:spLocks xmlns:a="http://schemas.openxmlformats.org/drawingml/2006/main" noGrp="1"/>
-          </p:cNvSpPr>
-          <p:nvPr/>
-        </p:nvSpPr>
-        <p:spPr>
-          <a:xfrm xmlns:a="http://schemas.openxmlformats.org/drawingml/2006/main">
-            <a:off x="962025" y="438150"/>
-            <a:ext cx="971550" cy="285750"/>
+      <p:sp>
+        <p:nvSpPr>
+          <p:cNvPr id="4" name="">
+            <a:extLst xmlns:a="http://schemas.openxmlformats.org/drawingml/2006/main">
+              <a:ext uri="{FF2B5EF4-FFF2-40B4-BE49-F238E27FC236}">
+                <a16:creationId xmlns:a16="http://schemas.microsoft.com/office/drawing/2014/main" id="{EBF1DADD-43DA-4FED-9A98-CB6355DB1E84}"/>
+              </a:ext>
+            </a:extLst>
+          </p:cNvPr>
+          <p:cNvSpPr>
+            <a:spLocks xmlns:a="http://schemas.openxmlformats.org/drawingml/2006/main" noGrp="1"/>
+          </p:cNvSpPr>
+          <p:nvPr/>
+        </p:nvSpPr>
+        <p:spPr>
+          <a:xfrm xmlns:a="http://schemas.openxmlformats.org/drawingml/2006/main">
+            <a:off x="476250" y="1066800"/>
+            <a:ext cx="3429000" cy="209550"/>
           </a:xfrm>
           <a:prstGeom xmlns:a="http://schemas.openxmlformats.org/drawingml/2006/main" prst="rect">
             <a:avLst/>
@@ -2305,47 +2249,47 @@
           <a:p xmlns:a="http://schemas.openxmlformats.org/drawingml/2006/main">
             <a:pPr algn="l">
               <a:buNone/>
-              <a:defRPr sz="1650" b="1">
-                <a:solidFill>
-                  <a:srgbClr val="F7FAF8"/>
-                </a:solidFill>
-                <a:latin typeface="Helvetica Neue"/>
-                <a:ea typeface="Helvetica Neue"/>
-                <a:cs typeface="Helvetica Neue"/>
-              </a:defRPr>
-            </a:pPr>
-            <a:r>
-              <a:rPr sz="1650" b="1">
-                <a:solidFill>
-                  <a:srgbClr val="F7FAF8"/>
-                </a:solidFill>
-                <a:latin typeface="Helvetica Neue"/>
-                <a:ea typeface="Helvetica Neue"/>
-                <a:cs typeface="Helvetica Neue"/>
-              </a:rPr>
-              <a:t>Chhotu</a:t>
-            </a:r>
-          </a:p>
-        </p:txBody>
-      </p:sp>
-      <p:sp>
-        <p:nvSpPr>
-          <p:cNvPr id="3" name="">
-            <a:extLst xmlns:a="http://schemas.openxmlformats.org/drawingml/2006/main">
-              <a:ext uri="{FF2B5EF4-FFF2-40B4-BE49-F238E27FC236}">
-                <a16:creationId xmlns:a16="http://schemas.microsoft.com/office/drawing/2014/main" id="{BCA1F038-623C-4280-B678-0B84CBB3B3BC}"/>
-              </a:ext>
-            </a:extLst>
-          </p:cNvPr>
-          <p:cNvSpPr>
-            <a:spLocks xmlns:a="http://schemas.openxmlformats.org/drawingml/2006/main" noGrp="1"/>
-          </p:cNvSpPr>
-          <p:nvPr/>
-        </p:nvSpPr>
-        <p:spPr>
-          <a:xfrm xmlns:a="http://schemas.openxmlformats.org/drawingml/2006/main">
-            <a:off x="1809750" y="438150"/>
-            <a:ext cx="476250" cy="285750"/>
+              <a:defRPr sz="900" b="1">
+                <a:solidFill>
+                  <a:srgbClr val="FFB34D"/>
+                </a:solidFill>
+                <a:latin typeface="Helvetica Neue"/>
+                <a:ea typeface="Helvetica Neue"/>
+                <a:cs typeface="Helvetica Neue"/>
+              </a:defRPr>
+            </a:pPr>
+            <a:r>
+              <a:rPr sz="900" b="1">
+                <a:solidFill>
+                  <a:srgbClr val="FFB34D"/>
+                </a:solidFill>
+                <a:latin typeface="Helvetica Neue"/>
+                <a:ea typeface="Helvetica Neue"/>
+                <a:cs typeface="Helvetica Neue"/>
+              </a:rPr>
+              <a:t>THE TRADE REALITY</a:t>
+            </a:r>
+          </a:p>
+        </p:txBody>
+      </p:sp>
+      <p:sp>
+        <p:nvSpPr>
+          <p:cNvPr id="5" name="">
+            <a:extLst xmlns:a="http://schemas.openxmlformats.org/drawingml/2006/main">
+              <a:ext uri="{FF2B5EF4-FFF2-40B4-BE49-F238E27FC236}">
+                <a16:creationId xmlns:a16="http://schemas.microsoft.com/office/drawing/2014/main" id="{1B998FAF-E5FB-4AF5-BD42-4A356C91DBC0}"/>
+              </a:ext>
+            </a:extLst>
+          </p:cNvPr>
+          <p:cNvSpPr>
+            <a:spLocks xmlns:a="http://schemas.openxmlformats.org/drawingml/2006/main" noGrp="1"/>
+          </p:cNvSpPr>
+          <p:nvPr/>
+        </p:nvSpPr>
+        <p:spPr>
+          <a:xfrm xmlns:a="http://schemas.openxmlformats.org/drawingml/2006/main">
+            <a:off x="476250" y="1381125"/>
+            <a:ext cx="9525000" cy="523875"/>
           </a:xfrm>
           <a:prstGeom xmlns:a="http://schemas.openxmlformats.org/drawingml/2006/main" prst="rect">
             <a:avLst/>
@@ -2364,47 +2308,47 @@
           <a:p xmlns:a="http://schemas.openxmlformats.org/drawingml/2006/main">
             <a:pPr algn="l">
               <a:buNone/>
-              <a:defRPr sz="1650" b="1">
-                <a:solidFill>
-                  <a:srgbClr val="6CF8BB"/>
-                </a:solidFill>
-                <a:latin typeface="Helvetica Neue"/>
-                <a:ea typeface="Helvetica Neue"/>
-                <a:cs typeface="Helvetica Neue"/>
-              </a:defRPr>
-            </a:pPr>
-            <a:r>
-              <a:rPr sz="1650" b="1">
-                <a:solidFill>
-                  <a:srgbClr val="6CF8BB"/>
-                </a:solidFill>
-                <a:latin typeface="Helvetica Neue"/>
-                <a:ea typeface="Helvetica Neue"/>
-                <a:cs typeface="Helvetica Neue"/>
-              </a:rPr>
-              <a:t>.ai</a:t>
-            </a:r>
-          </a:p>
-        </p:txBody>
-      </p:sp>
-      <p:sp>
-        <p:nvSpPr>
-          <p:cNvPr id="4" name="">
-            <a:extLst xmlns:a="http://schemas.openxmlformats.org/drawingml/2006/main">
-              <a:ext uri="{FF2B5EF4-FFF2-40B4-BE49-F238E27FC236}">
-                <a16:creationId xmlns:a16="http://schemas.microsoft.com/office/drawing/2014/main" id="{EBF1DADD-43DA-4FED-9A98-CB6355DB1E84}"/>
-              </a:ext>
-            </a:extLst>
-          </p:cNvPr>
-          <p:cNvSpPr>
-            <a:spLocks xmlns:a="http://schemas.openxmlformats.org/drawingml/2006/main" noGrp="1"/>
-          </p:cNvSpPr>
-          <p:nvPr/>
-        </p:nvSpPr>
-        <p:spPr>
-          <a:xfrm xmlns:a="http://schemas.openxmlformats.org/drawingml/2006/main">
-            <a:off x="476250" y="1066800"/>
-            <a:ext cx="3429000" cy="209550"/>
+              <a:defRPr sz="3000" b="1">
+                <a:solidFill>
+                  <a:srgbClr val="F7FAF8"/>
+                </a:solidFill>
+                <a:latin typeface="Helvetica Neue"/>
+                <a:ea typeface="Helvetica Neue"/>
+                <a:cs typeface="Helvetica Neue"/>
+              </a:defRPr>
+            </a:pPr>
+            <a:r>
+              <a:rPr sz="3000" b="1">
+                <a:solidFill>
+                  <a:srgbClr val="F7FAF8"/>
+                </a:solidFill>
+                <a:latin typeface="Helvetica Neue"/>
+                <a:ea typeface="Helvetica Neue"/>
+                <a:cs typeface="Helvetica Neue"/>
+              </a:rPr>
+              <a:t>Trade moves fast. Records still lag.</a:t>
+            </a:r>
+          </a:p>
+        </p:txBody>
+      </p:sp>
+      <p:sp>
+        <p:nvSpPr>
+          <p:cNvPr id="6" name="">
+            <a:extLst xmlns:a="http://schemas.openxmlformats.org/drawingml/2006/main">
+              <a:ext uri="{FF2B5EF4-FFF2-40B4-BE49-F238E27FC236}">
+                <a16:creationId xmlns:a16="http://schemas.microsoft.com/office/drawing/2014/main" id="{D52F71CD-CD68-472D-B87B-5FA96953EBE2}"/>
+              </a:ext>
+            </a:extLst>
+          </p:cNvPr>
+          <p:cNvSpPr>
+            <a:spLocks xmlns:a="http://schemas.openxmlformats.org/drawingml/2006/main" noGrp="1"/>
+          </p:cNvSpPr>
+          <p:nvPr/>
+        </p:nvSpPr>
+        <p:spPr>
+          <a:xfrm xmlns:a="http://schemas.openxmlformats.org/drawingml/2006/main">
+            <a:off x="476250" y="2095500"/>
+            <a:ext cx="3190875" cy="523875"/>
           </a:xfrm>
           <a:prstGeom xmlns:a="http://schemas.openxmlformats.org/drawingml/2006/main" prst="rect">
             <a:avLst/>
@@ -2423,47 +2367,47 @@
           <a:p xmlns:a="http://schemas.openxmlformats.org/drawingml/2006/main">
             <a:pPr algn="l">
               <a:buNone/>
-              <a:defRPr sz="900" b="1">
-                <a:solidFill>
-                  <a:srgbClr val="FFB34D"/>
-                </a:solidFill>
-                <a:latin typeface="Helvetica Neue"/>
-                <a:ea typeface="Helvetica Neue"/>
-                <a:cs typeface="Helvetica Neue"/>
-              </a:defRPr>
-            </a:pPr>
-            <a:r>
-              <a:rPr sz="900" b="1">
-                <a:solidFill>
-                  <a:srgbClr val="FFB34D"/>
-                </a:solidFill>
-                <a:latin typeface="Helvetica Neue"/>
-                <a:ea typeface="Helvetica Neue"/>
-                <a:cs typeface="Helvetica Neue"/>
-              </a:rPr>
-              <a:t>THE TRADE REALITY</a:t>
-            </a:r>
-          </a:p>
-        </p:txBody>
-      </p:sp>
-      <p:sp>
-        <p:nvSpPr>
-          <p:cNvPr id="5" name="">
-            <a:extLst xmlns:a="http://schemas.openxmlformats.org/drawingml/2006/main">
-              <a:ext uri="{FF2B5EF4-FFF2-40B4-BE49-F238E27FC236}">
-                <a16:creationId xmlns:a16="http://schemas.microsoft.com/office/drawing/2014/main" id="{1B998FAF-E5FB-4AF5-BD42-4A356C91DBC0}"/>
-              </a:ext>
-            </a:extLst>
-          </p:cNvPr>
-          <p:cNvSpPr>
-            <a:spLocks xmlns:a="http://schemas.openxmlformats.org/drawingml/2006/main" noGrp="1"/>
-          </p:cNvSpPr>
-          <p:nvPr/>
-        </p:nvSpPr>
-        <p:spPr>
-          <a:xfrm xmlns:a="http://schemas.openxmlformats.org/drawingml/2006/main">
-            <a:off x="476250" y="1381125"/>
-            <a:ext cx="9525000" cy="523875"/>
+              <a:defRPr sz="3000" b="1">
+                <a:solidFill>
+                  <a:srgbClr val="6CF8BB"/>
+                </a:solidFill>
+                <a:latin typeface="Helvetica Neue"/>
+                <a:ea typeface="Helvetica Neue"/>
+                <a:cs typeface="Helvetica Neue"/>
+              </a:defRPr>
+            </a:pPr>
+            <a:r>
+              <a:rPr sz="3000" b="1">
+                <a:solidFill>
+                  <a:srgbClr val="6CF8BB"/>
+                </a:solidFill>
+                <a:latin typeface="Helvetica Neue"/>
+                <a:ea typeface="Helvetica Neue"/>
+                <a:cs typeface="Helvetica Neue"/>
+              </a:rPr>
+              <a:t>2.28 crore</a:t>
+            </a:r>
+          </a:p>
+        </p:txBody>
+      </p:sp>
+      <p:sp>
+        <p:nvSpPr>
+          <p:cNvPr id="7" name="">
+            <a:extLst xmlns:a="http://schemas.openxmlformats.org/drawingml/2006/main">
+              <a:ext uri="{FF2B5EF4-FFF2-40B4-BE49-F238E27FC236}">
+                <a16:creationId xmlns:a16="http://schemas.microsoft.com/office/drawing/2014/main" id="{4B524CF0-8E93-43D2-B8A8-E49CD9154BE6}"/>
+              </a:ext>
+            </a:extLst>
+          </p:cNvPr>
+          <p:cNvSpPr>
+            <a:spLocks xmlns:a="http://schemas.openxmlformats.org/drawingml/2006/main" noGrp="1"/>
+          </p:cNvSpPr>
+          <p:nvPr/>
+        </p:nvSpPr>
+        <p:spPr>
+          <a:xfrm xmlns:a="http://schemas.openxmlformats.org/drawingml/2006/main">
+            <a:off x="476250" y="2647950"/>
+            <a:ext cx="3095625" cy="361950"/>
           </a:xfrm>
           <a:prstGeom xmlns:a="http://schemas.openxmlformats.org/drawingml/2006/main" prst="rect">
             <a:avLst/>
@@ -2482,124 +2426,6 @@
           <a:p xmlns:a="http://schemas.openxmlformats.org/drawingml/2006/main">
             <a:pPr algn="l">
               <a:buNone/>
-              <a:defRPr sz="3000" b="1">
-                <a:solidFill>
-                  <a:srgbClr val="F7FAF8"/>
-                </a:solidFill>
-                <a:latin typeface="Helvetica Neue"/>
-                <a:ea typeface="Helvetica Neue"/>
-                <a:cs typeface="Helvetica Neue"/>
-              </a:defRPr>
-            </a:pPr>
-            <a:r>
-              <a:rPr sz="3000" b="1">
-                <a:solidFill>
-                  <a:srgbClr val="F7FAF8"/>
-                </a:solidFill>
-                <a:latin typeface="Helvetica Neue"/>
-                <a:ea typeface="Helvetica Neue"/>
-                <a:cs typeface="Helvetica Neue"/>
-              </a:rPr>
-              <a:t>Trade moves fast. Records still lag.</a:t>
-            </a:r>
-          </a:p>
-        </p:txBody>
-      </p:sp>
-      <p:sp>
-        <p:nvSpPr>
-          <p:cNvPr id="6" name="">
-            <a:extLst xmlns:a="http://schemas.openxmlformats.org/drawingml/2006/main">
-              <a:ext uri="{FF2B5EF4-FFF2-40B4-BE49-F238E27FC236}">
-                <a16:creationId xmlns:a16="http://schemas.microsoft.com/office/drawing/2014/main" id="{D52F71CD-CD68-472D-B87B-5FA96953EBE2}"/>
-              </a:ext>
-            </a:extLst>
-          </p:cNvPr>
-          <p:cNvSpPr>
-            <a:spLocks xmlns:a="http://schemas.openxmlformats.org/drawingml/2006/main" noGrp="1"/>
-          </p:cNvSpPr>
-          <p:nvPr/>
-        </p:nvSpPr>
-        <p:spPr>
-          <a:xfrm xmlns:a="http://schemas.openxmlformats.org/drawingml/2006/main">
-            <a:off x="476250" y="2095500"/>
-            <a:ext cx="3190875" cy="523875"/>
-          </a:xfrm>
-          <a:prstGeom xmlns:a="http://schemas.openxmlformats.org/drawingml/2006/main" prst="rect">
-            <a:avLst/>
-          </a:prstGeom>
-          <a:noFill xmlns:a="http://schemas.openxmlformats.org/drawingml/2006/main"/>
-          <a:ln xmlns:a="http://schemas.openxmlformats.org/drawingml/2006/main" w="0">
-            <a:noFill/>
-            <a:prstDash val="solid"/>
-          </a:ln>
-        </p:spPr>
-        <p:txBody>
-          <a:bodyPr xmlns:a="http://schemas.openxmlformats.org/drawingml/2006/main" wrap="square" lIns="0" tIns="0" rIns="0" bIns="0" anchor="t">
-            <a:normAutofit fontScale="100000"/>
-          </a:bodyPr>
-          <a:lstStyle xmlns:a="http://schemas.openxmlformats.org/drawingml/2006/main"/>
-          <a:p xmlns:a="http://schemas.openxmlformats.org/drawingml/2006/main">
-            <a:pPr algn="l">
-              <a:buNone/>
-              <a:defRPr sz="3000" b="1">
-                <a:solidFill>
-                  <a:srgbClr val="6CF8BB"/>
-                </a:solidFill>
-                <a:latin typeface="Helvetica Neue"/>
-                <a:ea typeface="Helvetica Neue"/>
-                <a:cs typeface="Helvetica Neue"/>
-              </a:defRPr>
-            </a:pPr>
-            <a:r>
-              <a:rPr sz="3000" b="1">
-                <a:solidFill>
-                  <a:srgbClr val="6CF8BB"/>
-                </a:solidFill>
-                <a:latin typeface="Helvetica Neue"/>
-                <a:ea typeface="Helvetica Neue"/>
-                <a:cs typeface="Helvetica Neue"/>
-              </a:rPr>
-              <a:t>2.28 crore</a:t>
-            </a:r>
-          </a:p>
-        </p:txBody>
-      </p:sp>
-      <p:sp>
-        <p:nvSpPr>
-          <p:cNvPr id="7" name="">
-            <a:extLst xmlns:a="http://schemas.openxmlformats.org/drawingml/2006/main">
-              <a:ext uri="{FF2B5EF4-FFF2-40B4-BE49-F238E27FC236}">
-                <a16:creationId xmlns:a16="http://schemas.microsoft.com/office/drawing/2014/main" id="{4B524CF0-8E93-43D2-B8A8-E49CD9154BE6}"/>
-              </a:ext>
-            </a:extLst>
-          </p:cNvPr>
-          <p:cNvSpPr>
-            <a:spLocks xmlns:a="http://schemas.openxmlformats.org/drawingml/2006/main" noGrp="1"/>
-          </p:cNvSpPr>
-          <p:nvPr/>
-        </p:nvSpPr>
-        <p:spPr>
-          <a:xfrm xmlns:a="http://schemas.openxmlformats.org/drawingml/2006/main">
-            <a:off x="476250" y="2647950"/>
-            <a:ext cx="3095625" cy="361950"/>
-          </a:xfrm>
-          <a:prstGeom xmlns:a="http://schemas.openxmlformats.org/drawingml/2006/main" prst="rect">
-            <a:avLst/>
-          </a:prstGeom>
-          <a:noFill xmlns:a="http://schemas.openxmlformats.org/drawingml/2006/main"/>
-          <a:ln xmlns:a="http://schemas.openxmlformats.org/drawingml/2006/main" w="0">
-            <a:noFill/>
-            <a:prstDash val="solid"/>
-          </a:ln>
-        </p:spPr>
-        <p:txBody>
-          <a:bodyPr xmlns:a="http://schemas.openxmlformats.org/drawingml/2006/main" wrap="square" lIns="0" tIns="0" rIns="0" bIns="0" anchor="t">
-            <a:normAutofit fontScale="100000"/>
-          </a:bodyPr>
-          <a:lstStyle xmlns:a="http://schemas.openxmlformats.org/drawingml/2006/main"/>
-          <a:p xmlns:a="http://schemas.openxmlformats.org/drawingml/2006/main">
-            <a:pPr algn="l">
-              <a:buNone/>
               <a:defRPr sz="1200" b="0">
                 <a:solidFill>
                   <a:srgbClr val="9CA59F"/>
@@ -2625,7 +2451,7 @@
       </p:sp>
       <p:cxnSp>
         <p:nvCxnSpPr>
-          <p:cNvPr id="102" name=""/>
+          <p:cNvPr id="192" name=""/>
           <p:cNvCxnSpPr/>
           <p:nvPr/>
         </p:nvCxnSpPr>
@@ -2699,7 +2525,7 @@
                 <a:ea typeface="Helvetica Neue"/>
                 <a:cs typeface="Helvetica Neue"/>
               </a:rPr>
-              <a:t>26.7%</a:t>
+              <a:t>34.7%</a:t>
             </a:r>
           </a:p>
         </p:txBody>
@@ -2758,14 +2584,14 @@
                 <a:ea typeface="Helvetica Neue"/>
                 <a:cs typeface="Helvetica Neue"/>
               </a:rPr>
-              <a:t>internet use across sector</a:t>
+              <a:t>trade establishments using internet</a:t>
             </a:r>
           </a:p>
         </p:txBody>
       </p:sp>
       <p:cxnSp>
         <p:nvCxnSpPr>
-          <p:cNvPr id="105" name=""/>
+          <p:cNvPr id="195" name=""/>
           <p:cNvCxnSpPr/>
           <p:nvPr/>
         </p:nvCxnSpPr>
@@ -2898,7 +2724,7 @@
                 <a:ea typeface="Helvetica Neue"/>
                 <a:cs typeface="Helvetica Neue"/>
               </a:rPr>
-              <a:t>formal MSE claims on Samadhaan</a:t>
+              <a:t>delayed-payment claims filed by MSEs</a:t>
             </a:r>
           </a:p>
         </p:txBody>
@@ -3418,7 +3244,7 @@
                 <a:ea typeface="Helvetica Neue"/>
                 <a:cs typeface="Helvetica Neue"/>
               </a:rPr>
-              <a:t>Sources: MoSPI ASUSE 2023–24 trade facts; MSME Annual Report 2025–26. Trade includes wholesale + retail.</a:t>
+              <a:t>Sources: MoSPI ASUSE 2023–24; MSME Annual Report 2025–26. Trade includes wholesale + retail.</a:t>
             </a:r>
           </a:p>
         </p:txBody>
@@ -3478,6 +3304,114 @@
                 <a:cs typeface="Helvetica Neue"/>
               </a:rPr>
               <a:t>02</a:t>
+            </a:r>
+          </a:p>
+        </p:txBody>
+      </p:sp>
+      <p:pic>
+        <p:nvPicPr>
+          <p:cNvPr id="207" name=""/>
+          <p:cNvPicPr>
+            <a:picLocks xmlns:a="http://schemas.openxmlformats.org/drawingml/2006/main" noChangeAspect="1"/>
+          </p:cNvPicPr>
+          <p:nvPr/>
+        </p:nvPicPr>
+        <p:blipFill>
+          <a:blip xmlns:r="http://schemas.openxmlformats.org/officeDocument/2006/relationships" xmlns:a="http://schemas.openxmlformats.org/drawingml/2006/main" r:embed="R507c84bcc6b14fa2"/>
+          <a:stretch xmlns:a="http://schemas.openxmlformats.org/drawingml/2006/main"/>
+        </p:blipFill>
+        <p:spPr>
+          <a:xfrm xmlns:a="http://schemas.openxmlformats.org/drawingml/2006/main">
+            <a:off x="476250" y="342900"/>
+            <a:ext cx="266700" cy="266700"/>
+          </a:xfrm>
+          <a:prstGeom xmlns:a="http://schemas.openxmlformats.org/drawingml/2006/main" prst="rect">
+            <a:avLst/>
+          </a:prstGeom>
+        </p:spPr>
+      </p:pic>
+      <p:pic>
+        <p:nvPicPr>
+          <p:cNvPr id="208" name=""/>
+          <p:cNvPicPr>
+            <a:picLocks xmlns:a="http://schemas.openxmlformats.org/drawingml/2006/main" noChangeAspect="1"/>
+          </p:cNvPicPr>
+          <p:nvPr/>
+        </p:nvPicPr>
+        <p:blipFill>
+          <a:blip xmlns:r="http://schemas.openxmlformats.org/officeDocument/2006/relationships" xmlns:a="http://schemas.openxmlformats.org/drawingml/2006/main" r:embed="Re132a798efc94c06"/>
+          <a:stretch xmlns:a="http://schemas.openxmlformats.org/drawingml/2006/main"/>
+        </p:blipFill>
+        <p:spPr>
+          <a:xfrm xmlns:a="http://schemas.openxmlformats.org/drawingml/2006/main">
+            <a:off x="476250" y="342900"/>
+            <a:ext cx="266700" cy="266700"/>
+          </a:xfrm>
+          <a:prstGeom xmlns:a="http://schemas.openxmlformats.org/drawingml/2006/main" prst="rect">
+            <a:avLst/>
+          </a:prstGeom>
+        </p:spPr>
+      </p:pic>
+      <p:sp>
+        <p:nvSpPr>
+          <p:cNvPr id="187" name="Chhotu.ai wordmark">
+            <a:extLst xmlns:a="http://schemas.openxmlformats.org/drawingml/2006/main">
+              <a:ext uri="{FF2B5EF4-FFF2-40B4-BE49-F238E27FC236}">
+                <a16:creationId xmlns:a16="http://schemas.microsoft.com/office/drawing/2014/main" id="{ACDD1CAE-4B0D-4FA1-BD8B-F91620C0F769}"/>
+              </a:ext>
+            </a:extLst>
+          </p:cNvPr>
+          <p:cNvSpPr>
+            <a:spLocks xmlns:a="http://schemas.openxmlformats.org/drawingml/2006/main" noGrp="1"/>
+          </p:cNvSpPr>
+          <p:nvPr/>
+        </p:nvSpPr>
+        <p:spPr>
+          <a:xfrm xmlns:a="http://schemas.openxmlformats.org/drawingml/2006/main">
+            <a:off x="800100" y="314325"/>
+            <a:ext cx="1066800" cy="323850"/>
+          </a:xfrm>
+          <a:prstGeom xmlns:a="http://schemas.openxmlformats.org/drawingml/2006/main" prst="rect">
+            <a:avLst/>
+          </a:prstGeom>
+          <a:noFill xmlns:a="http://schemas.openxmlformats.org/drawingml/2006/main"/>
+          <a:ln xmlns:a="http://schemas.openxmlformats.org/drawingml/2006/main" w="0">
+            <a:noFill/>
+            <a:prstDash val="solid"/>
+          </a:ln>
+        </p:spPr>
+        <p:txBody>
+          <a:bodyPr xmlns:a="http://schemas.openxmlformats.org/drawingml/2006/main" anchor="ctr"/>
+          <a:lstStyle xmlns:a="http://schemas.openxmlformats.org/drawingml/2006/main"/>
+          <a:p xmlns:a="http://schemas.openxmlformats.org/drawingml/2006/main">
+            <a:pPr>
+              <a:defRPr sz="1500">
+                <a:latin typeface="Arial"/>
+                <a:ea typeface="Arial"/>
+                <a:cs typeface="Arial"/>
+              </a:defRPr>
+            </a:pPr>
+            <a:r>
+              <a:rPr sz="1500" b="1">
+                <a:solidFill>
+                  <a:srgbClr val="F7F8F8"/>
+                </a:solidFill>
+                <a:latin typeface="Arial"/>
+                <a:ea typeface="Arial"/>
+                <a:cs typeface="Arial"/>
+              </a:rPr>
+              <a:t>Chhotu</a:t>
+            </a:r>
+            <a:r>
+              <a:rPr sz="1500" b="1">
+                <a:solidFill>
+                  <a:srgbClr val="59F2BC"/>
+                </a:solidFill>
+                <a:latin typeface="Arial"/>
+                <a:ea typeface="Arial"/>
+                <a:cs typeface="Arial"/>
+              </a:rPr>
+              <a:t>.ai</a:t>
             </a:r>
           </a:p>
         </p:txBody>
@@ -3511,52 +3445,24 @@
       <p:grpSpPr>
         <a:xfrm xmlns:a="http://schemas.openxmlformats.org/drawingml/2006/main"/>
       </p:grpSpPr>
-      <p:pic>
-        <p:nvPicPr>
-          <p:cNvPr id="95" name=""/>
-          <p:cNvPicPr>
-            <a:picLocks xmlns:a="http://schemas.openxmlformats.org/drawingml/2006/main" noChangeAspect="1"/>
-          </p:cNvPicPr>
-          <p:nvPr/>
-        </p:nvPicPr>
-        <p:blipFill>
-          <a:blip xmlns:r="http://schemas.openxmlformats.org/officeDocument/2006/relationships" xmlns:a="http://schemas.openxmlformats.org/drawingml/2006/main" r:embed="R8ceda7e9d1594830">
-            <a:extLst>
-              <a:ext uri="{96DAC541-7B7A-43D3-8B79-37D633B846F1}">
-                <asvg:svgBlip xmlns:asvg="http://schemas.microsoft.com/office/drawing/2016/SVG/main" r:embed="R6b59d6f1dc05429d"/>
-              </a:ext>
-            </a:extLst>
-          </a:blip>
-          <a:stretch xmlns:a="http://schemas.openxmlformats.org/drawingml/2006/main"/>
-        </p:blipFill>
-        <p:spPr>
-          <a:xfrm xmlns:a="http://schemas.openxmlformats.org/drawingml/2006/main">
-            <a:off x="476250" y="400050"/>
-            <a:ext cx="381000" cy="381000"/>
-          </a:xfrm>
-          <a:prstGeom xmlns:a="http://schemas.openxmlformats.org/drawingml/2006/main" prst="rect">
-            <a:avLst/>
-          </a:prstGeom>
-        </p:spPr>
-      </p:pic>
-      <p:sp>
-        <p:nvSpPr>
-          <p:cNvPr id="2" name="">
-            <a:extLst xmlns:a="http://schemas.openxmlformats.org/drawingml/2006/main">
-              <a:ext uri="{FF2B5EF4-FFF2-40B4-BE49-F238E27FC236}">
-                <a16:creationId xmlns:a16="http://schemas.microsoft.com/office/drawing/2014/main" id="{2919991A-2719-40FB-BE0F-650209F2C6E7}"/>
-              </a:ext>
-            </a:extLst>
-          </p:cNvPr>
-          <p:cNvSpPr>
-            <a:spLocks xmlns:a="http://schemas.openxmlformats.org/drawingml/2006/main" noGrp="1"/>
-          </p:cNvSpPr>
-          <p:nvPr/>
-        </p:nvSpPr>
-        <p:spPr>
-          <a:xfrm xmlns:a="http://schemas.openxmlformats.org/drawingml/2006/main">
-            <a:off x="962025" y="438150"/>
-            <a:ext cx="971550" cy="285750"/>
+      <p:sp>
+        <p:nvSpPr>
+          <p:cNvPr id="4" name="">
+            <a:extLst xmlns:a="http://schemas.openxmlformats.org/drawingml/2006/main">
+              <a:ext uri="{FF2B5EF4-FFF2-40B4-BE49-F238E27FC236}">
+                <a16:creationId xmlns:a16="http://schemas.microsoft.com/office/drawing/2014/main" id="{4C8F3E85-70A3-4E49-A5B2-F9F61BA1FF9D}"/>
+              </a:ext>
+            </a:extLst>
+          </p:cNvPr>
+          <p:cNvSpPr>
+            <a:spLocks xmlns:a="http://schemas.openxmlformats.org/drawingml/2006/main" noGrp="1"/>
+          </p:cNvSpPr>
+          <p:nvPr/>
+        </p:nvSpPr>
+        <p:spPr>
+          <a:xfrm xmlns:a="http://schemas.openxmlformats.org/drawingml/2006/main">
+            <a:off x="476250" y="1066800"/>
+            <a:ext cx="2095500" cy="209550"/>
           </a:xfrm>
           <a:prstGeom xmlns:a="http://schemas.openxmlformats.org/drawingml/2006/main" prst="rect">
             <a:avLst/>
@@ -3575,7 +3481,66 @@
           <a:p xmlns:a="http://schemas.openxmlformats.org/drawingml/2006/main">
             <a:pPr algn="l">
               <a:buNone/>
-              <a:defRPr sz="1650" b="1">
+              <a:defRPr sz="900" b="1">
+                <a:solidFill>
+                  <a:srgbClr val="FFB34D"/>
+                </a:solidFill>
+                <a:latin typeface="Helvetica Neue"/>
+                <a:ea typeface="Helvetica Neue"/>
+                <a:cs typeface="Helvetica Neue"/>
+              </a:defRPr>
+            </a:pPr>
+            <a:r>
+              <a:rPr sz="900" b="1">
+                <a:solidFill>
+                  <a:srgbClr val="FFB34D"/>
+                </a:solidFill>
+                <a:latin typeface="Helvetica Neue"/>
+                <a:ea typeface="Helvetica Neue"/>
+                <a:cs typeface="Helvetica Neue"/>
+              </a:rPr>
+              <a:t>WHY SARVAM</a:t>
+            </a:r>
+          </a:p>
+        </p:txBody>
+      </p:sp>
+      <p:sp>
+        <p:nvSpPr>
+          <p:cNvPr id="5" name="">
+            <a:extLst xmlns:a="http://schemas.openxmlformats.org/drawingml/2006/main">
+              <a:ext uri="{FF2B5EF4-FFF2-40B4-BE49-F238E27FC236}">
+                <a16:creationId xmlns:a16="http://schemas.microsoft.com/office/drawing/2014/main" id="{6FF6FC44-4EDB-40E6-AFA8-9C87D1685250}"/>
+              </a:ext>
+            </a:extLst>
+          </p:cNvPr>
+          <p:cNvSpPr>
+            <a:spLocks xmlns:a="http://schemas.openxmlformats.org/drawingml/2006/main" noGrp="1"/>
+          </p:cNvSpPr>
+          <p:nvPr/>
+        </p:nvSpPr>
+        <p:spPr>
+          <a:xfrm xmlns:a="http://schemas.openxmlformats.org/drawingml/2006/main">
+            <a:off x="476250" y="1381125"/>
+            <a:ext cx="8763000" cy="523875"/>
+          </a:xfrm>
+          <a:prstGeom xmlns:a="http://schemas.openxmlformats.org/drawingml/2006/main" prst="rect">
+            <a:avLst/>
+          </a:prstGeom>
+          <a:noFill xmlns:a="http://schemas.openxmlformats.org/drawingml/2006/main"/>
+          <a:ln xmlns:a="http://schemas.openxmlformats.org/drawingml/2006/main" w="0">
+            <a:noFill/>
+            <a:prstDash val="solid"/>
+          </a:ln>
+        </p:spPr>
+        <p:txBody>
+          <a:bodyPr xmlns:a="http://schemas.openxmlformats.org/drawingml/2006/main" wrap="square" lIns="0" tIns="0" rIns="0" bIns="0" anchor="t">
+            <a:normAutofit fontScale="79749"/>
+          </a:bodyPr>
+          <a:lstStyle xmlns:a="http://schemas.openxmlformats.org/drawingml/2006/main"/>
+          <a:p xmlns:a="http://schemas.openxmlformats.org/drawingml/2006/main">
+            <a:pPr algn="l">
+              <a:buNone/>
+              <a:defRPr sz="3000" b="1">
                 <a:solidFill>
                   <a:srgbClr val="F7FAF8"/>
                 </a:solidFill>
@@ -3585,7 +3550,7 @@
               </a:defRPr>
             </a:pPr>
             <a:r>
-              <a:rPr sz="1650" b="1">
+              <a:rPr sz="3000" b="1">
                 <a:solidFill>
                   <a:srgbClr val="F7FAF8"/>
                 </a:solidFill>
@@ -3593,29 +3558,29 @@
                 <a:ea typeface="Helvetica Neue"/>
                 <a:cs typeface="Helvetica Neue"/>
               </a:rPr>
-              <a:t>Chhotu</a:t>
-            </a:r>
-          </a:p>
-        </p:txBody>
-      </p:sp>
-      <p:sp>
-        <p:nvSpPr>
-          <p:cNvPr id="3" name="">
-            <a:extLst xmlns:a="http://schemas.openxmlformats.org/drawingml/2006/main">
-              <a:ext uri="{FF2B5EF4-FFF2-40B4-BE49-F238E27FC236}">
-                <a16:creationId xmlns:a16="http://schemas.microsoft.com/office/drawing/2014/main" id="{33AFF770-1B15-45A6-BD1D-50769E2B7BA2}"/>
-              </a:ext>
-            </a:extLst>
-          </p:cNvPr>
-          <p:cNvSpPr>
-            <a:spLocks xmlns:a="http://schemas.openxmlformats.org/drawingml/2006/main" noGrp="1"/>
-          </p:cNvSpPr>
-          <p:nvPr/>
-        </p:nvSpPr>
-        <p:spPr>
-          <a:xfrm xmlns:a="http://schemas.openxmlformats.org/drawingml/2006/main">
-            <a:off x="1809750" y="438150"/>
-            <a:ext cx="476250" cy="285750"/>
+              <a:t>Sarvam turns Indian speech into grounded business actions.</a:t>
+            </a:r>
+          </a:p>
+        </p:txBody>
+      </p:sp>
+      <p:sp>
+        <p:nvSpPr>
+          <p:cNvPr id="6" name="">
+            <a:extLst xmlns:a="http://schemas.openxmlformats.org/drawingml/2006/main">
+              <a:ext uri="{FF2B5EF4-FFF2-40B4-BE49-F238E27FC236}">
+                <a16:creationId xmlns:a16="http://schemas.microsoft.com/office/drawing/2014/main" id="{8679D301-130D-4DC6-A00C-FAB2985741A7}"/>
+              </a:ext>
+            </a:extLst>
+          </p:cNvPr>
+          <p:cNvSpPr>
+            <a:spLocks xmlns:a="http://schemas.openxmlformats.org/drawingml/2006/main" noGrp="1"/>
+          </p:cNvSpPr>
+          <p:nvPr/>
+        </p:nvSpPr>
+        <p:spPr>
+          <a:xfrm xmlns:a="http://schemas.openxmlformats.org/drawingml/2006/main">
+            <a:off x="523875" y="2333625"/>
+            <a:ext cx="1809750" cy="523875"/>
           </a:xfrm>
           <a:prstGeom xmlns:a="http://schemas.openxmlformats.org/drawingml/2006/main" prst="rect">
             <a:avLst/>
@@ -3634,7 +3599,7 @@
           <a:p xmlns:a="http://schemas.openxmlformats.org/drawingml/2006/main">
             <a:pPr algn="l">
               <a:buNone/>
-              <a:defRPr sz="1650" b="1">
+              <a:defRPr sz="3225" b="1">
                 <a:solidFill>
                   <a:srgbClr val="6CF8BB"/>
                 </a:solidFill>
@@ -3644,7 +3609,7 @@
               </a:defRPr>
             </a:pPr>
             <a:r>
-              <a:rPr sz="1650" b="1">
+              <a:rPr sz="3225" b="1">
                 <a:solidFill>
                   <a:srgbClr val="6CF8BB"/>
                 </a:solidFill>
@@ -3652,29 +3617,29 @@
                 <a:ea typeface="Helvetica Neue"/>
                 <a:cs typeface="Helvetica Neue"/>
               </a:rPr>
-              <a:t>.ai</a:t>
-            </a:r>
-          </a:p>
-        </p:txBody>
-      </p:sp>
-      <p:sp>
-        <p:nvSpPr>
-          <p:cNvPr id="4" name="">
-            <a:extLst xmlns:a="http://schemas.openxmlformats.org/drawingml/2006/main">
-              <a:ext uri="{FF2B5EF4-FFF2-40B4-BE49-F238E27FC236}">
-                <a16:creationId xmlns:a16="http://schemas.microsoft.com/office/drawing/2014/main" id="{4C8F3E85-70A3-4E49-A5B2-F9F61BA1FF9D}"/>
-              </a:ext>
-            </a:extLst>
-          </p:cNvPr>
-          <p:cNvSpPr>
-            <a:spLocks xmlns:a="http://schemas.openxmlformats.org/drawingml/2006/main" noGrp="1"/>
-          </p:cNvSpPr>
-          <p:nvPr/>
-        </p:nvSpPr>
-        <p:spPr>
-          <a:xfrm xmlns:a="http://schemas.openxmlformats.org/drawingml/2006/main">
-            <a:off x="476250" y="1066800"/>
-            <a:ext cx="2095500" cy="209550"/>
+              <a:t>23</a:t>
+            </a:r>
+          </a:p>
+        </p:txBody>
+      </p:sp>
+      <p:sp>
+        <p:nvSpPr>
+          <p:cNvPr id="7" name="">
+            <a:extLst xmlns:a="http://schemas.openxmlformats.org/drawingml/2006/main">
+              <a:ext uri="{FF2B5EF4-FFF2-40B4-BE49-F238E27FC236}">
+                <a16:creationId xmlns:a16="http://schemas.microsoft.com/office/drawing/2014/main" id="{2F53770C-F052-4BC7-A6B0-966250DB979D}"/>
+              </a:ext>
+            </a:extLst>
+          </p:cNvPr>
+          <p:cNvSpPr>
+            <a:spLocks xmlns:a="http://schemas.openxmlformats.org/drawingml/2006/main" noGrp="1"/>
+          </p:cNvSpPr>
+          <p:nvPr/>
+        </p:nvSpPr>
+        <p:spPr>
+          <a:xfrm xmlns:a="http://schemas.openxmlformats.org/drawingml/2006/main">
+            <a:off x="2266950" y="2447925"/>
+            <a:ext cx="2095500" cy="333375"/>
           </a:xfrm>
           <a:prstGeom xmlns:a="http://schemas.openxmlformats.org/drawingml/2006/main" prst="rect">
             <a:avLst/>
@@ -3693,183 +3658,6 @@
           <a:p xmlns:a="http://schemas.openxmlformats.org/drawingml/2006/main">
             <a:pPr algn="l">
               <a:buNone/>
-              <a:defRPr sz="900" b="1">
-                <a:solidFill>
-                  <a:srgbClr val="FFB34D"/>
-                </a:solidFill>
-                <a:latin typeface="Helvetica Neue"/>
-                <a:ea typeface="Helvetica Neue"/>
-                <a:cs typeface="Helvetica Neue"/>
-              </a:defRPr>
-            </a:pPr>
-            <a:r>
-              <a:rPr sz="900" b="1">
-                <a:solidFill>
-                  <a:srgbClr val="FFB34D"/>
-                </a:solidFill>
-                <a:latin typeface="Helvetica Neue"/>
-                <a:ea typeface="Helvetica Neue"/>
-                <a:cs typeface="Helvetica Neue"/>
-              </a:rPr>
-              <a:t>WHY SARVAM</a:t>
-            </a:r>
-          </a:p>
-        </p:txBody>
-      </p:sp>
-      <p:sp>
-        <p:nvSpPr>
-          <p:cNvPr id="5" name="">
-            <a:extLst xmlns:a="http://schemas.openxmlformats.org/drawingml/2006/main">
-              <a:ext uri="{FF2B5EF4-FFF2-40B4-BE49-F238E27FC236}">
-                <a16:creationId xmlns:a16="http://schemas.microsoft.com/office/drawing/2014/main" id="{6FF6FC44-4EDB-40E6-AFA8-9C87D1685250}"/>
-              </a:ext>
-            </a:extLst>
-          </p:cNvPr>
-          <p:cNvSpPr>
-            <a:spLocks xmlns:a="http://schemas.openxmlformats.org/drawingml/2006/main" noGrp="1"/>
-          </p:cNvSpPr>
-          <p:nvPr/>
-        </p:nvSpPr>
-        <p:spPr>
-          <a:xfrm xmlns:a="http://schemas.openxmlformats.org/drawingml/2006/main">
-            <a:off x="476250" y="1381125"/>
-            <a:ext cx="8763000" cy="523875"/>
-          </a:xfrm>
-          <a:prstGeom xmlns:a="http://schemas.openxmlformats.org/drawingml/2006/main" prst="rect">
-            <a:avLst/>
-          </a:prstGeom>
-          <a:noFill xmlns:a="http://schemas.openxmlformats.org/drawingml/2006/main"/>
-          <a:ln xmlns:a="http://schemas.openxmlformats.org/drawingml/2006/main" w="0">
-            <a:noFill/>
-            <a:prstDash val="solid"/>
-          </a:ln>
-        </p:spPr>
-        <p:txBody>
-          <a:bodyPr xmlns:a="http://schemas.openxmlformats.org/drawingml/2006/main" wrap="square" lIns="0" tIns="0" rIns="0" bIns="0" anchor="t">
-            <a:normAutofit fontScale="91211"/>
-          </a:bodyPr>
-          <a:lstStyle xmlns:a="http://schemas.openxmlformats.org/drawingml/2006/main"/>
-          <a:p xmlns:a="http://schemas.openxmlformats.org/drawingml/2006/main">
-            <a:pPr algn="l">
-              <a:buNone/>
-              <a:defRPr sz="3000" b="1">
-                <a:solidFill>
-                  <a:srgbClr val="F7FAF8"/>
-                </a:solidFill>
-                <a:latin typeface="Helvetica Neue"/>
-                <a:ea typeface="Helvetica Neue"/>
-                <a:cs typeface="Helvetica Neue"/>
-              </a:defRPr>
-            </a:pPr>
-            <a:r>
-              <a:rPr sz="3000" b="1">
-                <a:solidFill>
-                  <a:srgbClr val="F7FAF8"/>
-                </a:solidFill>
-                <a:latin typeface="Helvetica Neue"/>
-                <a:ea typeface="Helvetica Neue"/>
-                <a:cs typeface="Helvetica Neue"/>
-              </a:rPr>
-              <a:t>Sarvam turns Indian speech and invoices into action.</a:t>
-            </a:r>
-          </a:p>
-        </p:txBody>
-      </p:sp>
-      <p:sp>
-        <p:nvSpPr>
-          <p:cNvPr id="6" name="">
-            <a:extLst xmlns:a="http://schemas.openxmlformats.org/drawingml/2006/main">
-              <a:ext uri="{FF2B5EF4-FFF2-40B4-BE49-F238E27FC236}">
-                <a16:creationId xmlns:a16="http://schemas.microsoft.com/office/drawing/2014/main" id="{8679D301-130D-4DC6-A00C-FAB2985741A7}"/>
-              </a:ext>
-            </a:extLst>
-          </p:cNvPr>
-          <p:cNvSpPr>
-            <a:spLocks xmlns:a="http://schemas.openxmlformats.org/drawingml/2006/main" noGrp="1"/>
-          </p:cNvSpPr>
-          <p:nvPr/>
-        </p:nvSpPr>
-        <p:spPr>
-          <a:xfrm xmlns:a="http://schemas.openxmlformats.org/drawingml/2006/main">
-            <a:off x="523875" y="2333625"/>
-            <a:ext cx="1809750" cy="523875"/>
-          </a:xfrm>
-          <a:prstGeom xmlns:a="http://schemas.openxmlformats.org/drawingml/2006/main" prst="rect">
-            <a:avLst/>
-          </a:prstGeom>
-          <a:noFill xmlns:a="http://schemas.openxmlformats.org/drawingml/2006/main"/>
-          <a:ln xmlns:a="http://schemas.openxmlformats.org/drawingml/2006/main" w="0">
-            <a:noFill/>
-            <a:prstDash val="solid"/>
-          </a:ln>
-        </p:spPr>
-        <p:txBody>
-          <a:bodyPr xmlns:a="http://schemas.openxmlformats.org/drawingml/2006/main" wrap="square" lIns="0" tIns="0" rIns="0" bIns="0" anchor="t">
-            <a:normAutofit fontScale="100000"/>
-          </a:bodyPr>
-          <a:lstStyle xmlns:a="http://schemas.openxmlformats.org/drawingml/2006/main"/>
-          <a:p xmlns:a="http://schemas.openxmlformats.org/drawingml/2006/main">
-            <a:pPr algn="l">
-              <a:buNone/>
-              <a:defRPr sz="3225" b="1">
-                <a:solidFill>
-                  <a:srgbClr val="6CF8BB"/>
-                </a:solidFill>
-                <a:latin typeface="Helvetica Neue"/>
-                <a:ea typeface="Helvetica Neue"/>
-                <a:cs typeface="Helvetica Neue"/>
-              </a:defRPr>
-            </a:pPr>
-            <a:r>
-              <a:rPr sz="3225" b="1">
-                <a:solidFill>
-                  <a:srgbClr val="6CF8BB"/>
-                </a:solidFill>
-                <a:latin typeface="Helvetica Neue"/>
-                <a:ea typeface="Helvetica Neue"/>
-                <a:cs typeface="Helvetica Neue"/>
-              </a:rPr>
-              <a:t>11</a:t>
-            </a:r>
-          </a:p>
-        </p:txBody>
-      </p:sp>
-      <p:sp>
-        <p:nvSpPr>
-          <p:cNvPr id="7" name="">
-            <a:extLst xmlns:a="http://schemas.openxmlformats.org/drawingml/2006/main">
-              <a:ext uri="{FF2B5EF4-FFF2-40B4-BE49-F238E27FC236}">
-                <a16:creationId xmlns:a16="http://schemas.microsoft.com/office/drawing/2014/main" id="{2F53770C-F052-4BC7-A6B0-966250DB979D}"/>
-              </a:ext>
-            </a:extLst>
-          </p:cNvPr>
-          <p:cNvSpPr>
-            <a:spLocks xmlns:a="http://schemas.openxmlformats.org/drawingml/2006/main" noGrp="1"/>
-          </p:cNvSpPr>
-          <p:nvPr/>
-        </p:nvSpPr>
-        <p:spPr>
-          <a:xfrm xmlns:a="http://schemas.openxmlformats.org/drawingml/2006/main">
-            <a:off x="2266950" y="2447925"/>
-            <a:ext cx="2095500" cy="333375"/>
-          </a:xfrm>
-          <a:prstGeom xmlns:a="http://schemas.openxmlformats.org/drawingml/2006/main" prst="rect">
-            <a:avLst/>
-          </a:prstGeom>
-          <a:noFill xmlns:a="http://schemas.openxmlformats.org/drawingml/2006/main"/>
-          <a:ln xmlns:a="http://schemas.openxmlformats.org/drawingml/2006/main" w="0">
-            <a:noFill/>
-            <a:prstDash val="solid"/>
-          </a:ln>
-        </p:spPr>
-        <p:txBody>
-          <a:bodyPr xmlns:a="http://schemas.openxmlformats.org/drawingml/2006/main" wrap="square" lIns="0" tIns="0" rIns="0" bIns="0" anchor="t">
-            <a:normAutofit fontScale="100000"/>
-          </a:bodyPr>
-          <a:lstStyle xmlns:a="http://schemas.openxmlformats.org/drawingml/2006/main"/>
-          <a:p xmlns:a="http://schemas.openxmlformats.org/drawingml/2006/main">
-            <a:pPr algn="l">
-              <a:buNone/>
               <a:defRPr sz="1275" b="1">
                 <a:solidFill>
                   <a:srgbClr val="9CA59F"/>
@@ -3888,14 +3676,14 @@
                 <a:ea typeface="Helvetica Neue"/>
                 <a:cs typeface="Helvetica Neue"/>
               </a:rPr>
-              <a:t>Samvaad languages</a:t>
+              <a:t>STT languages</a:t>
             </a:r>
           </a:p>
         </p:txBody>
       </p:sp>
       <p:cxnSp>
         <p:nvCxnSpPr>
-          <p:cNvPr id="102" name=""/>
+          <p:cNvPr id="192" name=""/>
           <p:cNvCxnSpPr/>
           <p:nvPr/>
         </p:nvCxnSpPr>
@@ -3969,7 +3757,7 @@
                 <a:ea typeface="Helvetica Neue"/>
                 <a:cs typeface="Helvetica Neue"/>
               </a:rPr>
-              <a:t>&lt;500ms</a:t>
+              <a:t>11</a:t>
             </a:r>
           </a:p>
         </p:txBody>
@@ -4028,14 +3816,14 @@
                 <a:ea typeface="Helvetica Neue"/>
                 <a:cs typeface="Helvetica Neue"/>
               </a:rPr>
-              <a:t>stated live latency</a:t>
+              <a:t>TTS languages</a:t>
             </a:r>
           </a:p>
         </p:txBody>
       </p:sp>
       <p:cxnSp>
         <p:nvCxnSpPr>
-          <p:cNvPr id="105" name=""/>
+          <p:cNvPr id="195" name=""/>
           <p:cNvCxnSpPr/>
           <p:nvPr/>
         </p:nvCxnSpPr>
@@ -4168,7 +3956,7 @@
                 <a:ea typeface="Helvetica Neue"/>
                 <a:cs typeface="Helvetica Neue"/>
               </a:rPr>
-              <a:t>Vision languages</a:t>
+              <a:t>document languages</a:t>
             </a:r>
           </a:p>
         </p:txBody>
@@ -4273,7 +4061,7 @@
         </p:spPr>
         <p:txBody>
           <a:bodyPr xmlns:a="http://schemas.openxmlformats.org/drawingml/2006/main" wrap="square" lIns="0" tIns="0" rIns="0" bIns="0" anchor="t">
-            <a:normAutofit fontScale="86806"/>
+            <a:normAutofit fontScale="99419"/>
           </a:bodyPr>
           <a:lstStyle xmlns:a="http://schemas.openxmlformats.org/drawingml/2006/main"/>
           <a:p xmlns:a="http://schemas.openxmlformats.org/drawingml/2006/main">
@@ -4297,7 +4085,7 @@
                 <a:ea typeface="Helvetica Neue"/>
                 <a:cs typeface="Helvetica Neue"/>
               </a:rPr>
-              <a:t>SAMVAAD: SPEECH → ACTION</a:t>
+              <a:t>THE LIVE VOICE LOOP</a:t>
             </a:r>
           </a:p>
         </p:txBody>
@@ -4356,7 +4144,7 @@
                 <a:ea typeface="Helvetica Neue"/>
                 <a:cs typeface="Helvetica Neue"/>
               </a:rPr>
-              <a:t>Accents + code-mixing</a:t>
+              <a:t>Saaras v3: speech → text</a:t>
             </a:r>
           </a:p>
           <a:p xmlns:a="http://schemas.openxmlformats.org/drawingml/2006/main">
@@ -4404,7 +4192,7 @@
                 <a:ea typeface="Helvetica Neue"/>
                 <a:cs typeface="Helvetica Neue"/>
               </a:rPr>
-              <a:t>Streaming turns + barge-in</a:t>
+              <a:t>Samvaad: context + tool calls</a:t>
             </a:r>
           </a:p>
           <a:p xmlns:a="http://schemas.openxmlformats.org/drawingml/2006/main">
@@ -4452,7 +4240,7 @@
                 <a:ea typeface="Helvetica Neue"/>
                 <a:cs typeface="Helvetica Neue"/>
               </a:rPr>
-              <a:t>Voice, web + WhatsApp</a:t>
+              <a:t>Bulbul v3: text → speech</a:t>
             </a:r>
           </a:p>
           <a:p xmlns:a="http://schemas.openxmlformats.org/drawingml/2006/main">
@@ -4500,7 +4288,7 @@
                 <a:ea typeface="Helvetica Neue"/>
                 <a:cs typeface="Helvetica Neue"/>
               </a:rPr>
-              <a:t>Grounded API tool calls</a:t>
+              <a:t>Barge-in for natural turns</a:t>
             </a:r>
           </a:p>
         </p:txBody>
@@ -4523,65 +4311,6 @@
           <a:xfrm xmlns:a="http://schemas.openxmlformats.org/drawingml/2006/main">
             <a:off x="8334375" y="2514600"/>
             <a:ext cx="2857500" cy="476250"/>
-          </a:xfrm>
-          <a:prstGeom xmlns:a="http://schemas.openxmlformats.org/drawingml/2006/main" prst="rect">
-            <a:avLst/>
-          </a:prstGeom>
-          <a:noFill xmlns:a="http://schemas.openxmlformats.org/drawingml/2006/main"/>
-          <a:ln xmlns:a="http://schemas.openxmlformats.org/drawingml/2006/main" w="0">
-            <a:noFill/>
-            <a:prstDash val="solid"/>
-          </a:ln>
-        </p:spPr>
-        <p:txBody>
-          <a:bodyPr xmlns:a="http://schemas.openxmlformats.org/drawingml/2006/main" wrap="square" lIns="0" tIns="0" rIns="0" bIns="0" anchor="t">
-            <a:normAutofit fontScale="95256"/>
-          </a:bodyPr>
-          <a:lstStyle xmlns:a="http://schemas.openxmlformats.org/drawingml/2006/main"/>
-          <a:p xmlns:a="http://schemas.openxmlformats.org/drawingml/2006/main">
-            <a:pPr algn="l">
-              <a:buNone/>
-              <a:defRPr sz="1800" b="1">
-                <a:solidFill>
-                  <a:srgbClr val="6CF8BB"/>
-                </a:solidFill>
-                <a:latin typeface="Helvetica Neue"/>
-                <a:ea typeface="Helvetica Neue"/>
-                <a:cs typeface="Helvetica Neue"/>
-              </a:defRPr>
-            </a:pPr>
-            <a:r>
-              <a:rPr sz="1800" b="1">
-                <a:solidFill>
-                  <a:srgbClr val="6CF8BB"/>
-                </a:solidFill>
-                <a:latin typeface="Helvetica Neue"/>
-                <a:ea typeface="Helvetica Neue"/>
-                <a:cs typeface="Helvetica Neue"/>
-              </a:rPr>
-              <a:t>VISION: INVOICE → STOCK</a:t>
-            </a:r>
-          </a:p>
-        </p:txBody>
-      </p:sp>
-      <p:sp>
-        <p:nvSpPr>
-          <p:cNvPr id="19" name="">
-            <a:extLst xmlns:a="http://schemas.openxmlformats.org/drawingml/2006/main">
-              <a:ext uri="{FF2B5EF4-FFF2-40B4-BE49-F238E27FC236}">
-                <a16:creationId xmlns:a16="http://schemas.microsoft.com/office/drawing/2014/main" id="{6668FC51-0136-4318-96CF-2C97EFCC8A5C}"/>
-              </a:ext>
-            </a:extLst>
-          </p:cNvPr>
-          <p:cNvSpPr>
-            <a:spLocks xmlns:a="http://schemas.openxmlformats.org/drawingml/2006/main" noGrp="1"/>
-          </p:cNvSpPr>
-          <p:nvPr/>
-        </p:nvSpPr>
-        <p:spPr>
-          <a:xfrm xmlns:a="http://schemas.openxmlformats.org/drawingml/2006/main">
-            <a:off x="8334375" y="3200400"/>
-            <a:ext cx="2857500" cy="2000250"/>
           </a:xfrm>
           <a:prstGeom xmlns:a="http://schemas.openxmlformats.org/drawingml/2006/main" prst="rect">
             <a:avLst/>
@@ -4600,134 +4329,47 @@
           <a:p xmlns:a="http://schemas.openxmlformats.org/drawingml/2006/main">
             <a:pPr algn="l">
               <a:buNone/>
-              <a:defRPr sz="1500" b="0">
-                <a:solidFill>
-                  <a:srgbClr val="F7FAF8"/>
-                </a:solidFill>
-                <a:latin typeface="Helvetica Neue"/>
-                <a:ea typeface="Helvetica Neue"/>
-                <a:cs typeface="Helvetica Neue"/>
-              </a:defRPr>
-            </a:pPr>
-            <a:r>
-              <a:rPr sz="1500" b="0">
-                <a:solidFill>
-                  <a:srgbClr val="F7FAF8"/>
-                </a:solidFill>
-                <a:latin typeface="Helvetica Neue"/>
-                <a:ea typeface="Helvetica Neue"/>
-                <a:cs typeface="Helvetica Neue"/>
-              </a:rPr>
-              <a:t>Photo / PDF / scan</a:t>
-            </a:r>
-          </a:p>
-          <a:p xmlns:a="http://schemas.openxmlformats.org/drawingml/2006/main">
-            <a:r>
-              <a:t/>
-            </a:r>
-          </a:p>
-          <a:p xmlns:a="http://schemas.openxmlformats.org/drawingml/2006/main">
-            <a:pPr algn="l">
-              <a:buNone/>
-              <a:defRPr sz="1500" b="0">
-                <a:solidFill>
-                  <a:srgbClr val="F7FAF8"/>
-                </a:solidFill>
-                <a:latin typeface="Helvetica Neue"/>
-                <a:ea typeface="Helvetica Neue"/>
-                <a:cs typeface="Helvetica Neue"/>
-              </a:defRPr>
-            </a:pPr>
-            <a:r>
-              <a:rPr sz="1500" b="0">
-                <a:solidFill>
-                  <a:srgbClr val="F7FAF8"/>
-                </a:solidFill>
-                <a:latin typeface="Helvetica Neue"/>
-                <a:ea typeface="Helvetica Neue"/>
-                <a:cs typeface="Helvetica Neue"/>
-              </a:rPr>
-              <a:t>Text, tables + layout</a:t>
-            </a:r>
-          </a:p>
-          <a:p xmlns:a="http://schemas.openxmlformats.org/drawingml/2006/main">
-            <a:r>
-              <a:t/>
-            </a:r>
-          </a:p>
-          <a:p xmlns:a="http://schemas.openxmlformats.org/drawingml/2006/main">
-            <a:pPr algn="l">
-              <a:buNone/>
-              <a:defRPr sz="1500" b="0">
-                <a:solidFill>
-                  <a:srgbClr val="F7FAF8"/>
-                </a:solidFill>
-                <a:latin typeface="Helvetica Neue"/>
-                <a:ea typeface="Helvetica Neue"/>
-                <a:cs typeface="Helvetica Neue"/>
-              </a:defRPr>
-            </a:pPr>
-            <a:r>
-              <a:rPr sz="1500" b="0">
-                <a:solidFill>
-                  <a:srgbClr val="F7FAF8"/>
-                </a:solidFill>
-                <a:latin typeface="Helvetica Neue"/>
-                <a:ea typeface="Helvetica Neue"/>
-                <a:cs typeface="Helvetica Neue"/>
-              </a:rPr>
-              <a:t>SKU, qty + GST extraction</a:t>
-            </a:r>
-          </a:p>
-          <a:p xmlns:a="http://schemas.openxmlformats.org/drawingml/2006/main">
-            <a:r>
-              <a:t/>
-            </a:r>
-          </a:p>
-          <a:p xmlns:a="http://schemas.openxmlformats.org/drawingml/2006/main">
-            <a:pPr algn="l">
-              <a:buNone/>
-              <a:defRPr sz="1500" b="0">
-                <a:solidFill>
-                  <a:srgbClr val="F7FAF8"/>
-                </a:solidFill>
-                <a:latin typeface="Helvetica Neue"/>
-                <a:ea typeface="Helvetica Neue"/>
-                <a:cs typeface="Helvetica Neue"/>
-              </a:defRPr>
-            </a:pPr>
-            <a:r>
-              <a:rPr sz="1500" b="0">
-                <a:solidFill>
-                  <a:srgbClr val="F7FAF8"/>
-                </a:solidFill>
-                <a:latin typeface="Helvetica Neue"/>
-                <a:ea typeface="Helvetica Neue"/>
-                <a:cs typeface="Helvetica Neue"/>
-              </a:rPr>
-              <a:t>Human review → inventory</a:t>
-            </a:r>
-          </a:p>
-        </p:txBody>
-      </p:sp>
-      <p:sp>
-        <p:nvSpPr>
-          <p:cNvPr id="20" name="">
-            <a:extLst xmlns:a="http://schemas.openxmlformats.org/drawingml/2006/main">
-              <a:ext uri="{FF2B5EF4-FFF2-40B4-BE49-F238E27FC236}">
-                <a16:creationId xmlns:a16="http://schemas.microsoft.com/office/drawing/2014/main" id="{2AF86A8E-E5C7-40B8-A37F-0DB28D157E29}"/>
-              </a:ext>
-            </a:extLst>
-          </p:cNvPr>
-          <p:cNvSpPr>
-            <a:spLocks xmlns:a="http://schemas.openxmlformats.org/drawingml/2006/main" noGrp="1"/>
-          </p:cNvSpPr>
-          <p:nvPr/>
-        </p:nvSpPr>
-        <p:spPr>
-          <a:xfrm xmlns:a="http://schemas.openxmlformats.org/drawingml/2006/main">
-            <a:off x="4619625" y="5905500"/>
-            <a:ext cx="7096125" cy="323850"/>
+              <a:defRPr sz="1800" b="1">
+                <a:solidFill>
+                  <a:srgbClr val="6CF8BB"/>
+                </a:solidFill>
+                <a:latin typeface="Helvetica Neue"/>
+                <a:ea typeface="Helvetica Neue"/>
+                <a:cs typeface="Helvetica Neue"/>
+              </a:defRPr>
+            </a:pPr>
+            <a:r>
+              <a:rPr sz="1800" b="1">
+                <a:solidFill>
+                  <a:srgbClr val="6CF8BB"/>
+                </a:solidFill>
+                <a:latin typeface="Helvetica Neue"/>
+                <a:ea typeface="Helvetica Neue"/>
+                <a:cs typeface="Helvetica Neue"/>
+              </a:rPr>
+              <a:t>WHY IT FITS INDIA</a:t>
+            </a:r>
+          </a:p>
+        </p:txBody>
+      </p:sp>
+      <p:sp>
+        <p:nvSpPr>
+          <p:cNvPr id="19" name="">
+            <a:extLst xmlns:a="http://schemas.openxmlformats.org/drawingml/2006/main">
+              <a:ext uri="{FF2B5EF4-FFF2-40B4-BE49-F238E27FC236}">
+                <a16:creationId xmlns:a16="http://schemas.microsoft.com/office/drawing/2014/main" id="{6668FC51-0136-4318-96CF-2C97EFCC8A5C}"/>
+              </a:ext>
+            </a:extLst>
+          </p:cNvPr>
+          <p:cNvSpPr>
+            <a:spLocks xmlns:a="http://schemas.openxmlformats.org/drawingml/2006/main" noGrp="1"/>
+          </p:cNvSpPr>
+          <p:nvPr/>
+        </p:nvSpPr>
+        <p:spPr>
+          <a:xfrm xmlns:a="http://schemas.openxmlformats.org/drawingml/2006/main">
+            <a:off x="8334375" y="3200400"/>
+            <a:ext cx="2857500" cy="2000250"/>
           </a:xfrm>
           <a:prstGeom xmlns:a="http://schemas.openxmlformats.org/drawingml/2006/main" prst="rect">
             <a:avLst/>
@@ -4744,49 +4386,136 @@
           </a:bodyPr>
           <a:lstStyle xmlns:a="http://schemas.openxmlformats.org/drawingml/2006/main"/>
           <a:p xmlns:a="http://schemas.openxmlformats.org/drawingml/2006/main">
-            <a:pPr algn="r">
-              <a:buNone/>
-              <a:defRPr sz="1200" b="1">
-                <a:solidFill>
-                  <a:srgbClr val="FFB34D"/>
-                </a:solidFill>
-                <a:latin typeface="Helvetica Neue"/>
-                <a:ea typeface="Helvetica Neue"/>
-                <a:cs typeface="Helvetica Neue"/>
-              </a:defRPr>
-            </a:pPr>
-            <a:r>
-              <a:rPr sz="1200" b="1">
-                <a:solidFill>
-                  <a:srgbClr val="FFB34D"/>
-                </a:solidFill>
-                <a:latin typeface="Helvetica Neue"/>
-                <a:ea typeface="Helvetica Neue"/>
-                <a:cs typeface="Helvetica Neue"/>
-              </a:rPr>
-              <a:t>Used live: multilingual conversation, grounded tools and document-to-stock workflows.</a:t>
-            </a:r>
-          </a:p>
-        </p:txBody>
-      </p:sp>
-      <p:sp>
-        <p:nvSpPr>
-          <p:cNvPr id="21" name="">
-            <a:extLst xmlns:a="http://schemas.openxmlformats.org/drawingml/2006/main">
-              <a:ext uri="{FF2B5EF4-FFF2-40B4-BE49-F238E27FC236}">
-                <a16:creationId xmlns:a16="http://schemas.microsoft.com/office/drawing/2014/main" id="{B009595A-E908-46F5-8C30-3C6FE7579EF7}"/>
-              </a:ext>
-            </a:extLst>
-          </p:cNvPr>
-          <p:cNvSpPr>
-            <a:spLocks xmlns:a="http://schemas.openxmlformats.org/drawingml/2006/main" noGrp="1"/>
-          </p:cNvSpPr>
-          <p:nvPr/>
-        </p:nvSpPr>
-        <p:spPr>
-          <a:xfrm xmlns:a="http://schemas.openxmlformats.org/drawingml/2006/main">
-            <a:off x="476250" y="6429375"/>
-            <a:ext cx="10287000" cy="190500"/>
+            <a:pPr algn="l">
+              <a:buNone/>
+              <a:defRPr sz="1500" b="0">
+                <a:solidFill>
+                  <a:srgbClr val="F7FAF8"/>
+                </a:solidFill>
+                <a:latin typeface="Helvetica Neue"/>
+                <a:ea typeface="Helvetica Neue"/>
+                <a:cs typeface="Helvetica Neue"/>
+              </a:defRPr>
+            </a:pPr>
+            <a:r>
+              <a:rPr sz="1500" b="0">
+                <a:solidFill>
+                  <a:srgbClr val="F7FAF8"/>
+                </a:solidFill>
+                <a:latin typeface="Helvetica Neue"/>
+                <a:ea typeface="Helvetica Neue"/>
+                <a:cs typeface="Helvetica Neue"/>
+              </a:rPr>
+              <a:t>Accents + code-mixing</a:t>
+            </a:r>
+          </a:p>
+          <a:p xmlns:a="http://schemas.openxmlformats.org/drawingml/2006/main">
+            <a:r>
+              <a:t/>
+            </a:r>
+          </a:p>
+          <a:p xmlns:a="http://schemas.openxmlformats.org/drawingml/2006/main">
+            <a:pPr algn="l">
+              <a:buNone/>
+              <a:defRPr sz="1500" b="0">
+                <a:solidFill>
+                  <a:srgbClr val="F7FAF8"/>
+                </a:solidFill>
+                <a:latin typeface="Helvetica Neue"/>
+                <a:ea typeface="Helvetica Neue"/>
+                <a:cs typeface="Helvetica Neue"/>
+              </a:defRPr>
+            </a:pPr>
+            <a:r>
+              <a:rPr sz="1500" b="0">
+                <a:solidFill>
+                  <a:srgbClr val="F7FAF8"/>
+                </a:solidFill>
+                <a:latin typeface="Helvetica Neue"/>
+                <a:ea typeface="Helvetica Neue"/>
+                <a:cs typeface="Helvetica Neue"/>
+              </a:rPr>
+              <a:t>Automatic language detection</a:t>
+            </a:r>
+          </a:p>
+          <a:p xmlns:a="http://schemas.openxmlformats.org/drawingml/2006/main">
+            <a:r>
+              <a:t/>
+            </a:r>
+          </a:p>
+          <a:p xmlns:a="http://schemas.openxmlformats.org/drawingml/2006/main">
+            <a:pPr algn="l">
+              <a:buNone/>
+              <a:defRPr sz="1500" b="0">
+                <a:solidFill>
+                  <a:srgbClr val="F7FAF8"/>
+                </a:solidFill>
+                <a:latin typeface="Helvetica Neue"/>
+                <a:ea typeface="Helvetica Neue"/>
+                <a:cs typeface="Helvetica Neue"/>
+              </a:defRPr>
+            </a:pPr>
+            <a:r>
+              <a:rPr sz="1500" b="0">
+                <a:solidFill>
+                  <a:srgbClr val="F7FAF8"/>
+                </a:solidFill>
+                <a:latin typeface="Helvetica Neue"/>
+                <a:ea typeface="Helvetica Neue"/>
+                <a:cs typeface="Helvetica Neue"/>
+              </a:rPr>
+              <a:t>English-normalised tool inputs</a:t>
+            </a:r>
+          </a:p>
+          <a:p xmlns:a="http://schemas.openxmlformats.org/drawingml/2006/main">
+            <a:r>
+              <a:t/>
+            </a:r>
+          </a:p>
+          <a:p xmlns:a="http://schemas.openxmlformats.org/drawingml/2006/main">
+            <a:pPr algn="l">
+              <a:buNone/>
+              <a:defRPr sz="1500" b="0">
+                <a:solidFill>
+                  <a:srgbClr val="F7FAF8"/>
+                </a:solidFill>
+                <a:latin typeface="Helvetica Neue"/>
+                <a:ea typeface="Helvetica Neue"/>
+                <a:cs typeface="Helvetica Neue"/>
+              </a:defRPr>
+            </a:pPr>
+            <a:r>
+              <a:rPr sz="1500" b="0">
+                <a:solidFill>
+                  <a:srgbClr val="F7FAF8"/>
+                </a:solidFill>
+                <a:latin typeface="Helvetica Neue"/>
+                <a:ea typeface="Helvetica Neue"/>
+                <a:cs typeface="Helvetica Neue"/>
+              </a:rPr>
+              <a:t>Vision: invoice → reviewed stock</a:t>
+            </a:r>
+          </a:p>
+        </p:txBody>
+      </p:sp>
+      <p:sp>
+        <p:nvSpPr>
+          <p:cNvPr id="20" name="">
+            <a:extLst xmlns:a="http://schemas.openxmlformats.org/drawingml/2006/main">
+              <a:ext uri="{FF2B5EF4-FFF2-40B4-BE49-F238E27FC236}">
+                <a16:creationId xmlns:a16="http://schemas.microsoft.com/office/drawing/2014/main" id="{2AF86A8E-E5C7-40B8-A37F-0DB28D157E29}"/>
+              </a:ext>
+            </a:extLst>
+          </p:cNvPr>
+          <p:cNvSpPr>
+            <a:spLocks xmlns:a="http://schemas.openxmlformats.org/drawingml/2006/main" noGrp="1"/>
+          </p:cNvSpPr>
+          <p:nvPr/>
+        </p:nvSpPr>
+        <p:spPr>
+          <a:xfrm xmlns:a="http://schemas.openxmlformats.org/drawingml/2006/main">
+            <a:off x="4619625" y="5905500"/>
+            <a:ext cx="7096125" cy="323850"/>
           </a:xfrm>
           <a:prstGeom xmlns:a="http://schemas.openxmlformats.org/drawingml/2006/main" prst="rect">
             <a:avLst/>
@@ -4803,49 +4532,49 @@
           </a:bodyPr>
           <a:lstStyle xmlns:a="http://schemas.openxmlformats.org/drawingml/2006/main"/>
           <a:p xmlns:a="http://schemas.openxmlformats.org/drawingml/2006/main">
-            <a:pPr algn="l">
-              <a:buNone/>
-              <a:defRPr sz="750" b="0">
-                <a:solidFill>
-                  <a:srgbClr val="68716C"/>
-                </a:solidFill>
-                <a:latin typeface="Helvetica Neue"/>
-                <a:ea typeface="Helvetica Neue"/>
-                <a:cs typeface="Helvetica Neue"/>
-              </a:defRPr>
-            </a:pPr>
-            <a:r>
-              <a:rPr sz="750" b="0">
-                <a:solidFill>
-                  <a:srgbClr val="68716C"/>
-                </a:solidFill>
-                <a:latin typeface="Helvetica Neue"/>
-                <a:ea typeface="Helvetica Neue"/>
-                <a:cs typeface="Helvetica Neue"/>
-              </a:rPr>
-              <a:t>Sources: Sarvam Samvaad, Sarvam Vision + Document Digitization docs.</a:t>
-            </a:r>
-          </a:p>
-        </p:txBody>
-      </p:sp>
-      <p:sp>
-        <p:nvSpPr>
-          <p:cNvPr id="22" name="">
-            <a:extLst xmlns:a="http://schemas.openxmlformats.org/drawingml/2006/main">
-              <a:ext uri="{FF2B5EF4-FFF2-40B4-BE49-F238E27FC236}">
-                <a16:creationId xmlns:a16="http://schemas.microsoft.com/office/drawing/2014/main" id="{B883FFE3-519E-4862-B469-018043BCF48A}"/>
-              </a:ext>
-            </a:extLst>
-          </p:cNvPr>
-          <p:cNvSpPr>
-            <a:spLocks xmlns:a="http://schemas.openxmlformats.org/drawingml/2006/main" noGrp="1"/>
-          </p:cNvSpPr>
-          <p:nvPr/>
-        </p:nvSpPr>
-        <p:spPr>
-          <a:xfrm xmlns:a="http://schemas.openxmlformats.org/drawingml/2006/main">
-            <a:off x="11334750" y="6381750"/>
-            <a:ext cx="361950" cy="171450"/>
+            <a:pPr algn="r">
+              <a:buNone/>
+              <a:defRPr sz="1200" b="1">
+                <a:solidFill>
+                  <a:srgbClr val="FFB34D"/>
+                </a:solidFill>
+                <a:latin typeface="Helvetica Neue"/>
+                <a:ea typeface="Helvetica Neue"/>
+                <a:cs typeface="Helvetica Neue"/>
+              </a:defRPr>
+            </a:pPr>
+            <a:r>
+              <a:rPr sz="1200" b="1">
+                <a:solidFill>
+                  <a:srgbClr val="FFB34D"/>
+                </a:solidFill>
+                <a:latin typeface="Helvetica Neue"/>
+                <a:ea typeface="Helvetica Neue"/>
+                <a:cs typeface="Helvetica Neue"/>
+              </a:rPr>
+              <a:t>Result: owners speak naturally; Chhotu writes only through validated business APIs.</a:t>
+            </a:r>
+          </a:p>
+        </p:txBody>
+      </p:sp>
+      <p:sp>
+        <p:nvSpPr>
+          <p:cNvPr id="21" name="">
+            <a:extLst xmlns:a="http://schemas.openxmlformats.org/drawingml/2006/main">
+              <a:ext uri="{FF2B5EF4-FFF2-40B4-BE49-F238E27FC236}">
+                <a16:creationId xmlns:a16="http://schemas.microsoft.com/office/drawing/2014/main" id="{B009595A-E908-46F5-8C30-3C6FE7579EF7}"/>
+              </a:ext>
+            </a:extLst>
+          </p:cNvPr>
+          <p:cNvSpPr>
+            <a:spLocks xmlns:a="http://schemas.openxmlformats.org/drawingml/2006/main" noGrp="1"/>
+          </p:cNvSpPr>
+          <p:nvPr/>
+        </p:nvSpPr>
+        <p:spPr>
+          <a:xfrm xmlns:a="http://schemas.openxmlformats.org/drawingml/2006/main">
+            <a:off x="476250" y="6429375"/>
+            <a:ext cx="10287000" cy="190500"/>
           </a:xfrm>
           <a:prstGeom xmlns:a="http://schemas.openxmlformats.org/drawingml/2006/main" prst="rect">
             <a:avLst/>
@@ -4862,6 +4591,65 @@
           </a:bodyPr>
           <a:lstStyle xmlns:a="http://schemas.openxmlformats.org/drawingml/2006/main"/>
           <a:p xmlns:a="http://schemas.openxmlformats.org/drawingml/2006/main">
+            <a:pPr algn="l">
+              <a:buNone/>
+              <a:defRPr sz="750" b="0">
+                <a:solidFill>
+                  <a:srgbClr val="68716C"/>
+                </a:solidFill>
+                <a:latin typeface="Helvetica Neue"/>
+                <a:ea typeface="Helvetica Neue"/>
+                <a:cs typeface="Helvetica Neue"/>
+              </a:defRPr>
+            </a:pPr>
+            <a:r>
+              <a:rPr sz="750" b="0">
+                <a:solidFill>
+                  <a:srgbClr val="68716C"/>
+                </a:solidFill>
+                <a:latin typeface="Helvetica Neue"/>
+                <a:ea typeface="Helvetica Neue"/>
+                <a:cs typeface="Helvetica Neue"/>
+              </a:rPr>
+              <a:t>Sources: Sarvam Samvaad, Sarvam Vision + Document Digitization docs.</a:t>
+            </a:r>
+          </a:p>
+        </p:txBody>
+      </p:sp>
+      <p:sp>
+        <p:nvSpPr>
+          <p:cNvPr id="22" name="">
+            <a:extLst xmlns:a="http://schemas.openxmlformats.org/drawingml/2006/main">
+              <a:ext uri="{FF2B5EF4-FFF2-40B4-BE49-F238E27FC236}">
+                <a16:creationId xmlns:a16="http://schemas.microsoft.com/office/drawing/2014/main" id="{B883FFE3-519E-4862-B469-018043BCF48A}"/>
+              </a:ext>
+            </a:extLst>
+          </p:cNvPr>
+          <p:cNvSpPr>
+            <a:spLocks xmlns:a="http://schemas.openxmlformats.org/drawingml/2006/main" noGrp="1"/>
+          </p:cNvSpPr>
+          <p:nvPr/>
+        </p:nvSpPr>
+        <p:spPr>
+          <a:xfrm xmlns:a="http://schemas.openxmlformats.org/drawingml/2006/main">
+            <a:off x="11334750" y="6381750"/>
+            <a:ext cx="361950" cy="171450"/>
+          </a:xfrm>
+          <a:prstGeom xmlns:a="http://schemas.openxmlformats.org/drawingml/2006/main" prst="rect">
+            <a:avLst/>
+          </a:prstGeom>
+          <a:noFill xmlns:a="http://schemas.openxmlformats.org/drawingml/2006/main"/>
+          <a:ln xmlns:a="http://schemas.openxmlformats.org/drawingml/2006/main" w="0">
+            <a:noFill/>
+            <a:prstDash val="solid"/>
+          </a:ln>
+        </p:spPr>
+        <p:txBody>
+          <a:bodyPr xmlns:a="http://schemas.openxmlformats.org/drawingml/2006/main" wrap="square" lIns="0" tIns="0" rIns="0" bIns="0" anchor="t">
+            <a:normAutofit fontScale="100000"/>
+          </a:bodyPr>
+          <a:lstStyle xmlns:a="http://schemas.openxmlformats.org/drawingml/2006/main"/>
+          <a:p xmlns:a="http://schemas.openxmlformats.org/drawingml/2006/main">
             <a:pPr algn="r">
               <a:buNone/>
               <a:defRPr sz="825" b="0">
@@ -4883,6 +4671,114 @@
                 <a:cs typeface="Helvetica Neue"/>
               </a:rPr>
               <a:t>03</a:t>
+            </a:r>
+          </a:p>
+        </p:txBody>
+      </p:sp>
+      <p:pic>
+        <p:nvPicPr>
+          <p:cNvPr id="207" name=""/>
+          <p:cNvPicPr>
+            <a:picLocks xmlns:a="http://schemas.openxmlformats.org/drawingml/2006/main" noChangeAspect="1"/>
+          </p:cNvPicPr>
+          <p:nvPr/>
+        </p:nvPicPr>
+        <p:blipFill>
+          <a:blip xmlns:r="http://schemas.openxmlformats.org/officeDocument/2006/relationships" xmlns:a="http://schemas.openxmlformats.org/drawingml/2006/main" r:embed="R166022ee76de47c2"/>
+          <a:stretch xmlns:a="http://schemas.openxmlformats.org/drawingml/2006/main"/>
+        </p:blipFill>
+        <p:spPr>
+          <a:xfrm xmlns:a="http://schemas.openxmlformats.org/drawingml/2006/main">
+            <a:off x="476250" y="342900"/>
+            <a:ext cx="266700" cy="266700"/>
+          </a:xfrm>
+          <a:prstGeom xmlns:a="http://schemas.openxmlformats.org/drawingml/2006/main" prst="rect">
+            <a:avLst/>
+          </a:prstGeom>
+        </p:spPr>
+      </p:pic>
+      <p:pic>
+        <p:nvPicPr>
+          <p:cNvPr id="208" name=""/>
+          <p:cNvPicPr>
+            <a:picLocks xmlns:a="http://schemas.openxmlformats.org/drawingml/2006/main" noChangeAspect="1"/>
+          </p:cNvPicPr>
+          <p:nvPr/>
+        </p:nvPicPr>
+        <p:blipFill>
+          <a:blip xmlns:r="http://schemas.openxmlformats.org/officeDocument/2006/relationships" xmlns:a="http://schemas.openxmlformats.org/drawingml/2006/main" r:embed="R7f8b80973f9d401c"/>
+          <a:stretch xmlns:a="http://schemas.openxmlformats.org/drawingml/2006/main"/>
+        </p:blipFill>
+        <p:spPr>
+          <a:xfrm xmlns:a="http://schemas.openxmlformats.org/drawingml/2006/main">
+            <a:off x="476250" y="342900"/>
+            <a:ext cx="266700" cy="266700"/>
+          </a:xfrm>
+          <a:prstGeom xmlns:a="http://schemas.openxmlformats.org/drawingml/2006/main" prst="rect">
+            <a:avLst/>
+          </a:prstGeom>
+        </p:spPr>
+      </p:pic>
+      <p:sp>
+        <p:nvSpPr>
+          <p:cNvPr id="187" name="Chhotu.ai wordmark">
+            <a:extLst xmlns:a="http://schemas.openxmlformats.org/drawingml/2006/main">
+              <a:ext uri="{FF2B5EF4-FFF2-40B4-BE49-F238E27FC236}">
+                <a16:creationId xmlns:a16="http://schemas.microsoft.com/office/drawing/2014/main" id="{67F3D5AD-D9C7-49CC-BAC5-537CB9279F71}"/>
+              </a:ext>
+            </a:extLst>
+          </p:cNvPr>
+          <p:cNvSpPr>
+            <a:spLocks xmlns:a="http://schemas.openxmlformats.org/drawingml/2006/main" noGrp="1"/>
+          </p:cNvSpPr>
+          <p:nvPr/>
+        </p:nvSpPr>
+        <p:spPr>
+          <a:xfrm xmlns:a="http://schemas.openxmlformats.org/drawingml/2006/main">
+            <a:off x="800100" y="314325"/>
+            <a:ext cx="1066800" cy="323850"/>
+          </a:xfrm>
+          <a:prstGeom xmlns:a="http://schemas.openxmlformats.org/drawingml/2006/main" prst="rect">
+            <a:avLst/>
+          </a:prstGeom>
+          <a:noFill xmlns:a="http://schemas.openxmlformats.org/drawingml/2006/main"/>
+          <a:ln xmlns:a="http://schemas.openxmlformats.org/drawingml/2006/main" w="0">
+            <a:noFill/>
+            <a:prstDash val="solid"/>
+          </a:ln>
+        </p:spPr>
+        <p:txBody>
+          <a:bodyPr xmlns:a="http://schemas.openxmlformats.org/drawingml/2006/main" anchor="ctr"/>
+          <a:lstStyle xmlns:a="http://schemas.openxmlformats.org/drawingml/2006/main"/>
+          <a:p xmlns:a="http://schemas.openxmlformats.org/drawingml/2006/main">
+            <a:pPr>
+              <a:defRPr sz="1500">
+                <a:latin typeface="Arial"/>
+                <a:ea typeface="Arial"/>
+                <a:cs typeface="Arial"/>
+              </a:defRPr>
+            </a:pPr>
+            <a:r>
+              <a:rPr sz="1500" b="1">
+                <a:solidFill>
+                  <a:srgbClr val="F7F8F8"/>
+                </a:solidFill>
+                <a:latin typeface="Arial"/>
+                <a:ea typeface="Arial"/>
+                <a:cs typeface="Arial"/>
+              </a:rPr>
+              <a:t>Chhotu</a:t>
+            </a:r>
+            <a:r>
+              <a:rPr sz="1500" b="1">
+                <a:solidFill>
+                  <a:srgbClr val="59F2BC"/>
+                </a:solidFill>
+                <a:latin typeface="Arial"/>
+                <a:ea typeface="Arial"/>
+                <a:cs typeface="Arial"/>
+              </a:rPr>
+              <a:t>.ai</a:t>
             </a:r>
           </a:p>
         </p:txBody>
@@ -4916,52 +4812,24 @@
       <p:grpSpPr>
         <a:xfrm xmlns:a="http://schemas.openxmlformats.org/drawingml/2006/main"/>
       </p:grpSpPr>
-      <p:pic>
-        <p:nvPicPr>
-          <p:cNvPr id="28" name=""/>
-          <p:cNvPicPr>
-            <a:picLocks xmlns:a="http://schemas.openxmlformats.org/drawingml/2006/main" noChangeAspect="1"/>
-          </p:cNvPicPr>
-          <p:nvPr/>
-        </p:nvPicPr>
-        <p:blipFill>
-          <a:blip xmlns:r="http://schemas.openxmlformats.org/officeDocument/2006/relationships" xmlns:a="http://schemas.openxmlformats.org/drawingml/2006/main" r:embed="Ra96d877722b74689">
-            <a:extLst>
-              <a:ext uri="{96DAC541-7B7A-43D3-8B79-37D633B846F1}">
-                <asvg:svgBlip xmlns:asvg="http://schemas.microsoft.com/office/drawing/2016/SVG/main" r:embed="Rad81726964044f15"/>
-              </a:ext>
-            </a:extLst>
-          </a:blip>
-          <a:stretch xmlns:a="http://schemas.openxmlformats.org/drawingml/2006/main"/>
-        </p:blipFill>
-        <p:spPr>
-          <a:xfrm xmlns:a="http://schemas.openxmlformats.org/drawingml/2006/main">
-            <a:off x="476250" y="400050"/>
-            <a:ext cx="381000" cy="381000"/>
-          </a:xfrm>
-          <a:prstGeom xmlns:a="http://schemas.openxmlformats.org/drawingml/2006/main" prst="rect">
-            <a:avLst/>
-          </a:prstGeom>
-        </p:spPr>
-      </p:pic>
-      <p:sp>
-        <p:nvSpPr>
-          <p:cNvPr id="2" name="">
-            <a:extLst xmlns:a="http://schemas.openxmlformats.org/drawingml/2006/main">
-              <a:ext uri="{FF2B5EF4-FFF2-40B4-BE49-F238E27FC236}">
-                <a16:creationId xmlns:a16="http://schemas.microsoft.com/office/drawing/2014/main" id="{3071AC61-944B-4789-8AC5-2BB308B47615}"/>
-              </a:ext>
-            </a:extLst>
-          </p:cNvPr>
-          <p:cNvSpPr>
-            <a:spLocks xmlns:a="http://schemas.openxmlformats.org/drawingml/2006/main" noGrp="1"/>
-          </p:cNvSpPr>
-          <p:nvPr/>
-        </p:nvSpPr>
-        <p:spPr>
-          <a:xfrm xmlns:a="http://schemas.openxmlformats.org/drawingml/2006/main">
-            <a:off x="962025" y="438150"/>
-            <a:ext cx="971550" cy="285750"/>
+      <p:sp>
+        <p:nvSpPr>
+          <p:cNvPr id="4" name="">
+            <a:extLst xmlns:a="http://schemas.openxmlformats.org/drawingml/2006/main">
+              <a:ext uri="{FF2B5EF4-FFF2-40B4-BE49-F238E27FC236}">
+                <a16:creationId xmlns:a16="http://schemas.microsoft.com/office/drawing/2014/main" id="{7AC671BB-5861-4747-BC82-7B1E632F5AD8}"/>
+              </a:ext>
+            </a:extLst>
+          </p:cNvPr>
+          <p:cNvSpPr>
+            <a:spLocks xmlns:a="http://schemas.openxmlformats.org/drawingml/2006/main" noGrp="1"/>
+          </p:cNvSpPr>
+          <p:nvPr/>
+        </p:nvSpPr>
+        <p:spPr>
+          <a:xfrm xmlns:a="http://schemas.openxmlformats.org/drawingml/2006/main">
+            <a:off x="476250" y="1066800"/>
+            <a:ext cx="2476500" cy="209550"/>
           </a:xfrm>
           <a:prstGeom xmlns:a="http://schemas.openxmlformats.org/drawingml/2006/main" prst="rect">
             <a:avLst/>
@@ -4980,47 +4848,47 @@
           <a:p xmlns:a="http://schemas.openxmlformats.org/drawingml/2006/main">
             <a:pPr algn="l">
               <a:buNone/>
-              <a:defRPr sz="1650" b="1">
-                <a:solidFill>
-                  <a:srgbClr val="111613"/>
-                </a:solidFill>
-                <a:latin typeface="Helvetica Neue"/>
-                <a:ea typeface="Helvetica Neue"/>
-                <a:cs typeface="Helvetica Neue"/>
-              </a:defRPr>
-            </a:pPr>
-            <a:r>
-              <a:rPr sz="1650" b="1">
-                <a:solidFill>
-                  <a:srgbClr val="111613"/>
-                </a:solidFill>
-                <a:latin typeface="Helvetica Neue"/>
-                <a:ea typeface="Helvetica Neue"/>
-                <a:cs typeface="Helvetica Neue"/>
-              </a:rPr>
-              <a:t>Chhotu</a:t>
-            </a:r>
-          </a:p>
-        </p:txBody>
-      </p:sp>
-      <p:sp>
-        <p:nvSpPr>
-          <p:cNvPr id="3" name="">
-            <a:extLst xmlns:a="http://schemas.openxmlformats.org/drawingml/2006/main">
-              <a:ext uri="{FF2B5EF4-FFF2-40B4-BE49-F238E27FC236}">
-                <a16:creationId xmlns:a16="http://schemas.microsoft.com/office/drawing/2014/main" id="{3C53E068-38DA-4FBA-AE50-6DDECDDE78B0}"/>
-              </a:ext>
-            </a:extLst>
-          </p:cNvPr>
-          <p:cNvSpPr>
-            <a:spLocks xmlns:a="http://schemas.openxmlformats.org/drawingml/2006/main" noGrp="1"/>
-          </p:cNvSpPr>
-          <p:nvPr/>
-        </p:nvSpPr>
-        <p:spPr>
-          <a:xfrm xmlns:a="http://schemas.openxmlformats.org/drawingml/2006/main">
-            <a:off x="1809750" y="438150"/>
-            <a:ext cx="476250" cy="285750"/>
+              <a:defRPr sz="900" b="1">
+                <a:solidFill>
+                  <a:srgbClr val="006C49"/>
+                </a:solidFill>
+                <a:latin typeface="Helvetica Neue"/>
+                <a:ea typeface="Helvetica Neue"/>
+                <a:cs typeface="Helvetica Neue"/>
+              </a:defRPr>
+            </a:pPr>
+            <a:r>
+              <a:rPr sz="900" b="1">
+                <a:solidFill>
+                  <a:srgbClr val="006C49"/>
+                </a:solidFill>
+                <a:latin typeface="Helvetica Neue"/>
+                <a:ea typeface="Helvetica Neue"/>
+                <a:cs typeface="Helvetica Neue"/>
+              </a:rPr>
+              <a:t>CURRENT PRODUCT / AVAILABLE NOW</a:t>
+            </a:r>
+          </a:p>
+        </p:txBody>
+      </p:sp>
+      <p:sp>
+        <p:nvSpPr>
+          <p:cNvPr id="5" name="">
+            <a:extLst xmlns:a="http://schemas.openxmlformats.org/drawingml/2006/main">
+              <a:ext uri="{FF2B5EF4-FFF2-40B4-BE49-F238E27FC236}">
+                <a16:creationId xmlns:a16="http://schemas.microsoft.com/office/drawing/2014/main" id="{DA322289-4A4D-418B-8529-F1B5352ABE84}"/>
+              </a:ext>
+            </a:extLst>
+          </p:cNvPr>
+          <p:cNvSpPr>
+            <a:spLocks xmlns:a="http://schemas.openxmlformats.org/drawingml/2006/main" noGrp="1"/>
+          </p:cNvSpPr>
+          <p:nvPr/>
+        </p:nvSpPr>
+        <p:spPr>
+          <a:xfrm xmlns:a="http://schemas.openxmlformats.org/drawingml/2006/main">
+            <a:off x="476250" y="1381125"/>
+            <a:ext cx="8953500" cy="523875"/>
           </a:xfrm>
           <a:prstGeom xmlns:a="http://schemas.openxmlformats.org/drawingml/2006/main" prst="rect">
             <a:avLst/>
@@ -5039,47 +4907,47 @@
           <a:p xmlns:a="http://schemas.openxmlformats.org/drawingml/2006/main">
             <a:pPr algn="l">
               <a:buNone/>
-              <a:defRPr sz="1650" b="1">
-                <a:solidFill>
-                  <a:srgbClr val="006C49"/>
-                </a:solidFill>
-                <a:latin typeface="Helvetica Neue"/>
-                <a:ea typeface="Helvetica Neue"/>
-                <a:cs typeface="Helvetica Neue"/>
-              </a:defRPr>
-            </a:pPr>
-            <a:r>
-              <a:rPr sz="1650" b="1">
-                <a:solidFill>
-                  <a:srgbClr val="006C49"/>
-                </a:solidFill>
-                <a:latin typeface="Helvetica Neue"/>
-                <a:ea typeface="Helvetica Neue"/>
-                <a:cs typeface="Helvetica Neue"/>
-              </a:rPr>
-              <a:t>.ai</a:t>
-            </a:r>
-          </a:p>
-        </p:txBody>
-      </p:sp>
-      <p:sp>
-        <p:nvSpPr>
-          <p:cNvPr id="4" name="">
-            <a:extLst xmlns:a="http://schemas.openxmlformats.org/drawingml/2006/main">
-              <a:ext uri="{FF2B5EF4-FFF2-40B4-BE49-F238E27FC236}">
-                <a16:creationId xmlns:a16="http://schemas.microsoft.com/office/drawing/2014/main" id="{7AC671BB-5861-4747-BC82-7B1E632F5AD8}"/>
-              </a:ext>
-            </a:extLst>
-          </p:cNvPr>
-          <p:cNvSpPr>
-            <a:spLocks xmlns:a="http://schemas.openxmlformats.org/drawingml/2006/main" noGrp="1"/>
-          </p:cNvSpPr>
-          <p:nvPr/>
-        </p:nvSpPr>
-        <p:spPr>
-          <a:xfrm xmlns:a="http://schemas.openxmlformats.org/drawingml/2006/main">
-            <a:off x="476250" y="1066800"/>
-            <a:ext cx="2476500" cy="209550"/>
+              <a:defRPr sz="3000" b="1">
+                <a:solidFill>
+                  <a:srgbClr val="111613"/>
+                </a:solidFill>
+                <a:latin typeface="Helvetica Neue"/>
+                <a:ea typeface="Helvetica Neue"/>
+                <a:cs typeface="Helvetica Neue"/>
+              </a:defRPr>
+            </a:pPr>
+            <a:r>
+              <a:rPr sz="3000" b="1">
+                <a:solidFill>
+                  <a:srgbClr val="111613"/>
+                </a:solidFill>
+                <a:latin typeface="Helvetica Neue"/>
+                <a:ea typeface="Helvetica Neue"/>
+                <a:cs typeface="Helvetica Neue"/>
+              </a:rPr>
+              <a:t>What Chhotu.ai does today.</a:t>
+            </a:r>
+          </a:p>
+        </p:txBody>
+      </p:sp>
+      <p:sp>
+        <p:nvSpPr>
+          <p:cNvPr id="6" name="">
+            <a:extLst xmlns:a="http://schemas.openxmlformats.org/drawingml/2006/main">
+              <a:ext uri="{FF2B5EF4-FFF2-40B4-BE49-F238E27FC236}">
+                <a16:creationId xmlns:a16="http://schemas.microsoft.com/office/drawing/2014/main" id="{52257E59-F1EB-4CE1-A064-AE5DC05B751F}"/>
+              </a:ext>
+            </a:extLst>
+          </p:cNvPr>
+          <p:cNvSpPr>
+            <a:spLocks xmlns:a="http://schemas.openxmlformats.org/drawingml/2006/main" noGrp="1"/>
+          </p:cNvSpPr>
+          <p:nvPr/>
+        </p:nvSpPr>
+        <p:spPr>
+          <a:xfrm xmlns:a="http://schemas.openxmlformats.org/drawingml/2006/main">
+            <a:off x="476250" y="1952625"/>
+            <a:ext cx="7620000" cy="323850"/>
           </a:xfrm>
           <a:prstGeom xmlns:a="http://schemas.openxmlformats.org/drawingml/2006/main" prst="rect">
             <a:avLst/>
@@ -5098,124 +4966,6 @@
           <a:p xmlns:a="http://schemas.openxmlformats.org/drawingml/2006/main">
             <a:pPr algn="l">
               <a:buNone/>
-              <a:defRPr sz="900" b="1">
-                <a:solidFill>
-                  <a:srgbClr val="006C49"/>
-                </a:solidFill>
-                <a:latin typeface="Helvetica Neue"/>
-                <a:ea typeface="Helvetica Neue"/>
-                <a:cs typeface="Helvetica Neue"/>
-              </a:defRPr>
-            </a:pPr>
-            <a:r>
-              <a:rPr sz="900" b="1">
-                <a:solidFill>
-                  <a:srgbClr val="006C49"/>
-                </a:solidFill>
-                <a:latin typeface="Helvetica Neue"/>
-                <a:ea typeface="Helvetica Neue"/>
-                <a:cs typeface="Helvetica Neue"/>
-              </a:rPr>
-              <a:t>LIVE / HARDWARE-FIRST</a:t>
-            </a:r>
-          </a:p>
-        </p:txBody>
-      </p:sp>
-      <p:sp>
-        <p:nvSpPr>
-          <p:cNvPr id="5" name="">
-            <a:extLst xmlns:a="http://schemas.openxmlformats.org/drawingml/2006/main">
-              <a:ext uri="{FF2B5EF4-FFF2-40B4-BE49-F238E27FC236}">
-                <a16:creationId xmlns:a16="http://schemas.microsoft.com/office/drawing/2014/main" id="{DA322289-4A4D-418B-8529-F1B5352ABE84}"/>
-              </a:ext>
-            </a:extLst>
-          </p:cNvPr>
-          <p:cNvSpPr>
-            <a:spLocks xmlns:a="http://schemas.openxmlformats.org/drawingml/2006/main" noGrp="1"/>
-          </p:cNvSpPr>
-          <p:nvPr/>
-        </p:nvSpPr>
-        <p:spPr>
-          <a:xfrm xmlns:a="http://schemas.openxmlformats.org/drawingml/2006/main">
-            <a:off x="476250" y="1381125"/>
-            <a:ext cx="8953500" cy="523875"/>
-          </a:xfrm>
-          <a:prstGeom xmlns:a="http://schemas.openxmlformats.org/drawingml/2006/main" prst="rect">
-            <a:avLst/>
-          </a:prstGeom>
-          <a:noFill xmlns:a="http://schemas.openxmlformats.org/drawingml/2006/main"/>
-          <a:ln xmlns:a="http://schemas.openxmlformats.org/drawingml/2006/main" w="0">
-            <a:noFill/>
-            <a:prstDash val="solid"/>
-          </a:ln>
-        </p:spPr>
-        <p:txBody>
-          <a:bodyPr xmlns:a="http://schemas.openxmlformats.org/drawingml/2006/main" wrap="square" lIns="0" tIns="0" rIns="0" bIns="0" anchor="t">
-            <a:normAutofit fontScale="100000"/>
-          </a:bodyPr>
-          <a:lstStyle xmlns:a="http://schemas.openxmlformats.org/drawingml/2006/main"/>
-          <a:p xmlns:a="http://schemas.openxmlformats.org/drawingml/2006/main">
-            <a:pPr algn="l">
-              <a:buNone/>
-              <a:defRPr sz="3000" b="1">
-                <a:solidFill>
-                  <a:srgbClr val="111613"/>
-                </a:solidFill>
-                <a:latin typeface="Helvetica Neue"/>
-                <a:ea typeface="Helvetica Neue"/>
-                <a:cs typeface="Helvetica Neue"/>
-              </a:defRPr>
-            </a:pPr>
-            <a:r>
-              <a:rPr sz="3000" b="1">
-                <a:solidFill>
-                  <a:srgbClr val="111613"/>
-                </a:solidFill>
-                <a:latin typeface="Helvetica Neue"/>
-                <a:ea typeface="Helvetica Neue"/>
-                <a:cs typeface="Helvetica Neue"/>
-              </a:rPr>
-              <a:t>A complete operating system for trade.</a:t>
-            </a:r>
-          </a:p>
-        </p:txBody>
-      </p:sp>
-      <p:sp>
-        <p:nvSpPr>
-          <p:cNvPr id="6" name="">
-            <a:extLst xmlns:a="http://schemas.openxmlformats.org/drawingml/2006/main">
-              <a:ext uri="{FF2B5EF4-FFF2-40B4-BE49-F238E27FC236}">
-                <a16:creationId xmlns:a16="http://schemas.microsoft.com/office/drawing/2014/main" id="{52257E59-F1EB-4CE1-A064-AE5DC05B751F}"/>
-              </a:ext>
-            </a:extLst>
-          </p:cNvPr>
-          <p:cNvSpPr>
-            <a:spLocks xmlns:a="http://schemas.openxmlformats.org/drawingml/2006/main" noGrp="1"/>
-          </p:cNvSpPr>
-          <p:nvPr/>
-        </p:nvSpPr>
-        <p:spPr>
-          <a:xfrm xmlns:a="http://schemas.openxmlformats.org/drawingml/2006/main">
-            <a:off x="476250" y="1952625"/>
-            <a:ext cx="7620000" cy="323850"/>
-          </a:xfrm>
-          <a:prstGeom xmlns:a="http://schemas.openxmlformats.org/drawingml/2006/main" prst="rect">
-            <a:avLst/>
-          </a:prstGeom>
-          <a:noFill xmlns:a="http://schemas.openxmlformats.org/drawingml/2006/main"/>
-          <a:ln xmlns:a="http://schemas.openxmlformats.org/drawingml/2006/main" w="0">
-            <a:noFill/>
-            <a:prstDash val="solid"/>
-          </a:ln>
-        </p:spPr>
-        <p:txBody>
-          <a:bodyPr xmlns:a="http://schemas.openxmlformats.org/drawingml/2006/main" wrap="square" lIns="0" tIns="0" rIns="0" bIns="0" anchor="t">
-            <a:normAutofit fontScale="100000"/>
-          </a:bodyPr>
-          <a:lstStyle xmlns:a="http://schemas.openxmlformats.org/drawingml/2006/main"/>
-          <a:p xmlns:a="http://schemas.openxmlformats.org/drawingml/2006/main">
-            <a:pPr algn="l">
-              <a:buNone/>
               <a:defRPr sz="1350" b="0">
                 <a:solidFill>
                   <a:srgbClr val="66706A"/>
@@ -5234,7 +4984,7 @@
                 <a:ea typeface="Helvetica Neue"/>
                 <a:cs typeface="Helvetica Neue"/>
               </a:rPr>
-              <a:t>For retailers, wholesalers and distributors: voice in front, auditable ledgers underneath.</a:t>
+              <a:t>Live workflows for hardware retailers, wholesalers and distributors.</a:t>
             </a:r>
           </a:p>
         </p:txBody>
@@ -5328,7 +5078,7 @@
                 <a:ea typeface="Helvetica Neue"/>
                 <a:cs typeface="Helvetica Neue"/>
               </a:rPr>
-              <a:t>01 / VOICE</a:t>
+              <a:t>AVAILABLE NOW / VOICE</a:t>
             </a:r>
           </a:p>
         </p:txBody>
@@ -5540,7 +5290,7 @@
                 <a:ea typeface="Helvetica Neue"/>
                 <a:cs typeface="Helvetica Neue"/>
               </a:rPr>
-              <a:t>02 / INVENTORY</a:t>
+              <a:t>AVAILABLE NOW / INVENTORY</a:t>
             </a:r>
           </a:p>
         </p:txBody>
@@ -5752,7 +5502,7 @@
                 <a:ea typeface="Helvetica Neue"/>
                 <a:cs typeface="Helvetica Neue"/>
               </a:rPr>
-              <a:t>03 / CRM + BILLING</a:t>
+              <a:t>AVAILABLE NOW / CRM + BILLING</a:t>
             </a:r>
           </a:p>
         </p:txBody>
@@ -5964,7 +5714,7 @@
                 <a:ea typeface="Helvetica Neue"/>
                 <a:cs typeface="Helvetica Neue"/>
               </a:rPr>
-              <a:t>04 / DOCUMENT AI</a:t>
+              <a:t>AVAILABLE NOW / DOCUMENT AI</a:t>
             </a:r>
           </a:p>
         </p:txBody>
@@ -6233,7 +5983,7 @@
                 <a:ea typeface="Helvetica Neue"/>
                 <a:cs typeface="Helvetica Neue"/>
               </a:rPr>
-              <a:t>VOICE  •  LEDGER  •  CRM  •  DOCUMENTS — GROUNDED</a:t>
+              <a:t>CURRENT: VOICE  •  INVENTORY  •  CRM  •  DOCUMENT AI</a:t>
             </a:r>
           </a:p>
         </p:txBody>
@@ -6293,6 +6043,114 @@
                 <a:cs typeface="Helvetica Neue"/>
               </a:rPr>
               <a:t>04</a:t>
+            </a:r>
+          </a:p>
+        </p:txBody>
+      </p:sp>
+      <p:pic>
+        <p:nvPicPr>
+          <p:cNvPr id="59" name=""/>
+          <p:cNvPicPr>
+            <a:picLocks xmlns:a="http://schemas.openxmlformats.org/drawingml/2006/main" noChangeAspect="1"/>
+          </p:cNvPicPr>
+          <p:nvPr/>
+        </p:nvPicPr>
+        <p:blipFill>
+          <a:blip xmlns:r="http://schemas.openxmlformats.org/officeDocument/2006/relationships" xmlns:a="http://schemas.openxmlformats.org/drawingml/2006/main" r:embed="R5d510ccced444cd8"/>
+          <a:stretch xmlns:a="http://schemas.openxmlformats.org/drawingml/2006/main"/>
+        </p:blipFill>
+        <p:spPr>
+          <a:xfrm xmlns:a="http://schemas.openxmlformats.org/drawingml/2006/main">
+            <a:off x="476250" y="342900"/>
+            <a:ext cx="266700" cy="266700"/>
+          </a:xfrm>
+          <a:prstGeom xmlns:a="http://schemas.openxmlformats.org/drawingml/2006/main" prst="rect">
+            <a:avLst/>
+          </a:prstGeom>
+        </p:spPr>
+      </p:pic>
+      <p:pic>
+        <p:nvPicPr>
+          <p:cNvPr id="60" name=""/>
+          <p:cNvPicPr>
+            <a:picLocks xmlns:a="http://schemas.openxmlformats.org/drawingml/2006/main" noChangeAspect="1"/>
+          </p:cNvPicPr>
+          <p:nvPr/>
+        </p:nvPicPr>
+        <p:blipFill>
+          <a:blip xmlns:r="http://schemas.openxmlformats.org/officeDocument/2006/relationships" xmlns:a="http://schemas.openxmlformats.org/drawingml/2006/main" r:embed="R006190b81be44ab8"/>
+          <a:stretch xmlns:a="http://schemas.openxmlformats.org/drawingml/2006/main"/>
+        </p:blipFill>
+        <p:spPr>
+          <a:xfrm xmlns:a="http://schemas.openxmlformats.org/drawingml/2006/main">
+            <a:off x="476250" y="342900"/>
+            <a:ext cx="266700" cy="266700"/>
+          </a:xfrm>
+          <a:prstGeom xmlns:a="http://schemas.openxmlformats.org/drawingml/2006/main" prst="rect">
+            <a:avLst/>
+          </a:prstGeom>
+        </p:spPr>
+      </p:pic>
+      <p:sp>
+        <p:nvSpPr>
+          <p:cNvPr id="35" name="Chhotu.ai wordmark">
+            <a:extLst xmlns:a="http://schemas.openxmlformats.org/drawingml/2006/main">
+              <a:ext uri="{FF2B5EF4-FFF2-40B4-BE49-F238E27FC236}">
+                <a16:creationId xmlns:a16="http://schemas.microsoft.com/office/drawing/2014/main" id="{1828AE8B-1C29-4741-89EA-1B7732694902}"/>
+              </a:ext>
+            </a:extLst>
+          </p:cNvPr>
+          <p:cNvSpPr>
+            <a:spLocks xmlns:a="http://schemas.openxmlformats.org/drawingml/2006/main" noGrp="1"/>
+          </p:cNvSpPr>
+          <p:nvPr/>
+        </p:nvSpPr>
+        <p:spPr>
+          <a:xfrm xmlns:a="http://schemas.openxmlformats.org/drawingml/2006/main">
+            <a:off x="800100" y="314325"/>
+            <a:ext cx="1066800" cy="323850"/>
+          </a:xfrm>
+          <a:prstGeom xmlns:a="http://schemas.openxmlformats.org/drawingml/2006/main" prst="rect">
+            <a:avLst/>
+          </a:prstGeom>
+          <a:noFill xmlns:a="http://schemas.openxmlformats.org/drawingml/2006/main"/>
+          <a:ln xmlns:a="http://schemas.openxmlformats.org/drawingml/2006/main" w="0">
+            <a:noFill/>
+            <a:prstDash val="solid"/>
+          </a:ln>
+        </p:spPr>
+        <p:txBody>
+          <a:bodyPr xmlns:a="http://schemas.openxmlformats.org/drawingml/2006/main" anchor="ctr"/>
+          <a:lstStyle xmlns:a="http://schemas.openxmlformats.org/drawingml/2006/main"/>
+          <a:p xmlns:a="http://schemas.openxmlformats.org/drawingml/2006/main">
+            <a:pPr>
+              <a:defRPr sz="1500">
+                <a:latin typeface="Arial"/>
+                <a:ea typeface="Arial"/>
+                <a:cs typeface="Arial"/>
+              </a:defRPr>
+            </a:pPr>
+            <a:r>
+              <a:rPr sz="1500" b="1">
+                <a:solidFill>
+                  <a:srgbClr val="111814"/>
+                </a:solidFill>
+                <a:latin typeface="Arial"/>
+                <a:ea typeface="Arial"/>
+                <a:cs typeface="Arial"/>
+              </a:rPr>
+              <a:t>Chhotu</a:t>
+            </a:r>
+            <a:r>
+              <a:rPr sz="1500" b="1">
+                <a:solidFill>
+                  <a:srgbClr val="00865F"/>
+                </a:solidFill>
+                <a:latin typeface="Arial"/>
+                <a:ea typeface="Arial"/>
+                <a:cs typeface="Arial"/>
+              </a:rPr>
+              <a:t>.ai</a:t>
             </a:r>
           </a:p>
         </p:txBody>
@@ -6326,52 +6184,24 @@
       <p:grpSpPr>
         <a:xfrm xmlns:a="http://schemas.openxmlformats.org/drawingml/2006/main"/>
       </p:grpSpPr>
-      <p:pic>
-        <p:nvPicPr>
-          <p:cNvPr id="28" name=""/>
-          <p:cNvPicPr>
-            <a:picLocks xmlns:a="http://schemas.openxmlformats.org/drawingml/2006/main" noChangeAspect="1"/>
-          </p:cNvPicPr>
-          <p:nvPr/>
-        </p:nvPicPr>
-        <p:blipFill>
-          <a:blip xmlns:r="http://schemas.openxmlformats.org/officeDocument/2006/relationships" xmlns:a="http://schemas.openxmlformats.org/drawingml/2006/main" r:embed="Rac9ce8ae3a5149a4">
-            <a:extLst>
-              <a:ext uri="{96DAC541-7B7A-43D3-8B79-37D633B846F1}">
-                <asvg:svgBlip xmlns:asvg="http://schemas.microsoft.com/office/drawing/2016/SVG/main" r:embed="R46bd2baeffc84904"/>
-              </a:ext>
-            </a:extLst>
-          </a:blip>
-          <a:stretch xmlns:a="http://schemas.openxmlformats.org/drawingml/2006/main"/>
-        </p:blipFill>
-        <p:spPr>
-          <a:xfrm xmlns:a="http://schemas.openxmlformats.org/drawingml/2006/main">
-            <a:off x="476250" y="400050"/>
-            <a:ext cx="381000" cy="381000"/>
-          </a:xfrm>
-          <a:prstGeom xmlns:a="http://schemas.openxmlformats.org/drawingml/2006/main" prst="rect">
-            <a:avLst/>
-          </a:prstGeom>
-        </p:spPr>
-      </p:pic>
-      <p:sp>
-        <p:nvSpPr>
-          <p:cNvPr id="2" name="">
-            <a:extLst xmlns:a="http://schemas.openxmlformats.org/drawingml/2006/main">
-              <a:ext uri="{FF2B5EF4-FFF2-40B4-BE49-F238E27FC236}">
-                <a16:creationId xmlns:a16="http://schemas.microsoft.com/office/drawing/2014/main" id="{3071AC61-944B-4789-8AC5-2BB308B47615}"/>
-              </a:ext>
-            </a:extLst>
-          </p:cNvPr>
-          <p:cNvSpPr>
-            <a:spLocks xmlns:a="http://schemas.openxmlformats.org/drawingml/2006/main" noGrp="1"/>
-          </p:cNvSpPr>
-          <p:nvPr/>
-        </p:nvSpPr>
-        <p:spPr>
-          <a:xfrm xmlns:a="http://schemas.openxmlformats.org/drawingml/2006/main">
-            <a:off x="962025" y="438150"/>
-            <a:ext cx="971550" cy="285750"/>
+      <p:sp>
+        <p:nvSpPr>
+          <p:cNvPr id="4" name="">
+            <a:extLst xmlns:a="http://schemas.openxmlformats.org/drawingml/2006/main">
+              <a:ext uri="{FF2B5EF4-FFF2-40B4-BE49-F238E27FC236}">
+                <a16:creationId xmlns:a16="http://schemas.microsoft.com/office/drawing/2014/main" id="{7AC671BB-5861-4747-BC82-7B1E632F5AD8}"/>
+              </a:ext>
+            </a:extLst>
+          </p:cNvPr>
+          <p:cNvSpPr>
+            <a:spLocks xmlns:a="http://schemas.openxmlformats.org/drawingml/2006/main" noGrp="1"/>
+          </p:cNvSpPr>
+          <p:nvPr/>
+        </p:nvSpPr>
+        <p:spPr>
+          <a:xfrm xmlns:a="http://schemas.openxmlformats.org/drawingml/2006/main">
+            <a:off x="476250" y="1066800"/>
+            <a:ext cx="2476500" cy="209550"/>
           </a:xfrm>
           <a:prstGeom xmlns:a="http://schemas.openxmlformats.org/drawingml/2006/main" prst="rect">
             <a:avLst/>
@@ -6390,47 +6220,47 @@
           <a:p xmlns:a="http://schemas.openxmlformats.org/drawingml/2006/main">
             <a:pPr algn="l">
               <a:buNone/>
-              <a:defRPr sz="1650" b="1">
-                <a:solidFill>
-                  <a:srgbClr val="111613"/>
-                </a:solidFill>
-                <a:latin typeface="Helvetica Neue"/>
-                <a:ea typeface="Helvetica Neue"/>
-                <a:cs typeface="Helvetica Neue"/>
-              </a:defRPr>
-            </a:pPr>
-            <a:r>
-              <a:rPr sz="1650" b="1">
-                <a:solidFill>
-                  <a:srgbClr val="111613"/>
-                </a:solidFill>
-                <a:latin typeface="Helvetica Neue"/>
-                <a:ea typeface="Helvetica Neue"/>
-                <a:cs typeface="Helvetica Neue"/>
-              </a:rPr>
-              <a:t>Chhotu</a:t>
-            </a:r>
-          </a:p>
-        </p:txBody>
-      </p:sp>
-      <p:sp>
-        <p:nvSpPr>
-          <p:cNvPr id="3" name="">
-            <a:extLst xmlns:a="http://schemas.openxmlformats.org/drawingml/2006/main">
-              <a:ext uri="{FF2B5EF4-FFF2-40B4-BE49-F238E27FC236}">
-                <a16:creationId xmlns:a16="http://schemas.microsoft.com/office/drawing/2014/main" id="{3C53E068-38DA-4FBA-AE50-6DDECDDE78B0}"/>
-              </a:ext>
-            </a:extLst>
-          </p:cNvPr>
-          <p:cNvSpPr>
-            <a:spLocks xmlns:a="http://schemas.openxmlformats.org/drawingml/2006/main" noGrp="1"/>
-          </p:cNvSpPr>
-          <p:nvPr/>
-        </p:nvSpPr>
-        <p:spPr>
-          <a:xfrm xmlns:a="http://schemas.openxmlformats.org/drawingml/2006/main">
-            <a:off x="1809750" y="438150"/>
-            <a:ext cx="476250" cy="285750"/>
+              <a:defRPr sz="900" b="1">
+                <a:solidFill>
+                  <a:srgbClr val="006C49"/>
+                </a:solidFill>
+                <a:latin typeface="Helvetica Neue"/>
+                <a:ea typeface="Helvetica Neue"/>
+                <a:cs typeface="Helvetica Neue"/>
+              </a:defRPr>
+            </a:pPr>
+            <a:r>
+              <a:rPr sz="900" b="1">
+                <a:solidFill>
+                  <a:srgbClr val="006C49"/>
+                </a:solidFill>
+                <a:latin typeface="Helvetica Neue"/>
+                <a:ea typeface="Helvetica Neue"/>
+                <a:cs typeface="Helvetica Neue"/>
+              </a:rPr>
+              <a:t>FUTURE ROADMAP / NOT CURRENT</a:t>
+            </a:r>
+          </a:p>
+        </p:txBody>
+      </p:sp>
+      <p:sp>
+        <p:nvSpPr>
+          <p:cNvPr id="5" name="">
+            <a:extLst xmlns:a="http://schemas.openxmlformats.org/drawingml/2006/main">
+              <a:ext uri="{FF2B5EF4-FFF2-40B4-BE49-F238E27FC236}">
+                <a16:creationId xmlns:a16="http://schemas.microsoft.com/office/drawing/2014/main" id="{DA322289-4A4D-418B-8529-F1B5352ABE84}"/>
+              </a:ext>
+            </a:extLst>
+          </p:cNvPr>
+          <p:cNvSpPr>
+            <a:spLocks xmlns:a="http://schemas.openxmlformats.org/drawingml/2006/main" noGrp="1"/>
+          </p:cNvSpPr>
+          <p:nvPr/>
+        </p:nvSpPr>
+        <p:spPr>
+          <a:xfrm xmlns:a="http://schemas.openxmlformats.org/drawingml/2006/main">
+            <a:off x="476250" y="1381125"/>
+            <a:ext cx="8953500" cy="523875"/>
           </a:xfrm>
           <a:prstGeom xmlns:a="http://schemas.openxmlformats.org/drawingml/2006/main" prst="rect">
             <a:avLst/>
@@ -6449,47 +6279,47 @@
           <a:p xmlns:a="http://schemas.openxmlformats.org/drawingml/2006/main">
             <a:pPr algn="l">
               <a:buNone/>
-              <a:defRPr sz="1650" b="1">
-                <a:solidFill>
-                  <a:srgbClr val="006C49"/>
-                </a:solidFill>
-                <a:latin typeface="Helvetica Neue"/>
-                <a:ea typeface="Helvetica Neue"/>
-                <a:cs typeface="Helvetica Neue"/>
-              </a:defRPr>
-            </a:pPr>
-            <a:r>
-              <a:rPr sz="1650" b="1">
-                <a:solidFill>
-                  <a:srgbClr val="006C49"/>
-                </a:solidFill>
-                <a:latin typeface="Helvetica Neue"/>
-                <a:ea typeface="Helvetica Neue"/>
-                <a:cs typeface="Helvetica Neue"/>
-              </a:rPr>
-              <a:t>.ai</a:t>
-            </a:r>
-          </a:p>
-        </p:txBody>
-      </p:sp>
-      <p:sp>
-        <p:nvSpPr>
-          <p:cNvPr id="4" name="">
-            <a:extLst xmlns:a="http://schemas.openxmlformats.org/drawingml/2006/main">
-              <a:ext uri="{FF2B5EF4-FFF2-40B4-BE49-F238E27FC236}">
-                <a16:creationId xmlns:a16="http://schemas.microsoft.com/office/drawing/2014/main" id="{7AC671BB-5861-4747-BC82-7B1E632F5AD8}"/>
-              </a:ext>
-            </a:extLst>
-          </p:cNvPr>
-          <p:cNvSpPr>
-            <a:spLocks xmlns:a="http://schemas.openxmlformats.org/drawingml/2006/main" noGrp="1"/>
-          </p:cNvSpPr>
-          <p:nvPr/>
-        </p:nvSpPr>
-        <p:spPr>
-          <a:xfrm xmlns:a="http://schemas.openxmlformats.org/drawingml/2006/main">
-            <a:off x="476250" y="1066800"/>
-            <a:ext cx="2476500" cy="209550"/>
+              <a:defRPr sz="3000" b="1">
+                <a:solidFill>
+                  <a:srgbClr val="111613"/>
+                </a:solidFill>
+                <a:latin typeface="Helvetica Neue"/>
+                <a:ea typeface="Helvetica Neue"/>
+                <a:cs typeface="Helvetica Neue"/>
+              </a:defRPr>
+            </a:pPr>
+            <a:r>
+              <a:rPr sz="3000" b="1">
+                <a:solidFill>
+                  <a:srgbClr val="111613"/>
+                </a:solidFill>
+                <a:latin typeface="Helvetica Neue"/>
+                <a:ea typeface="Helvetica Neue"/>
+                <a:cs typeface="Helvetica Neue"/>
+              </a:rPr>
+              <a:t>What Chhotu.ai becomes next.</a:t>
+            </a:r>
+          </a:p>
+        </p:txBody>
+      </p:sp>
+      <p:sp>
+        <p:nvSpPr>
+          <p:cNvPr id="6" name="">
+            <a:extLst xmlns:a="http://schemas.openxmlformats.org/drawingml/2006/main">
+              <a:ext uri="{FF2B5EF4-FFF2-40B4-BE49-F238E27FC236}">
+                <a16:creationId xmlns:a16="http://schemas.microsoft.com/office/drawing/2014/main" id="{52257E59-F1EB-4CE1-A064-AE5DC05B751F}"/>
+              </a:ext>
+            </a:extLst>
+          </p:cNvPr>
+          <p:cNvSpPr>
+            <a:spLocks xmlns:a="http://schemas.openxmlformats.org/drawingml/2006/main" noGrp="1"/>
+          </p:cNvSpPr>
+          <p:nvPr/>
+        </p:nvSpPr>
+        <p:spPr>
+          <a:xfrm xmlns:a="http://schemas.openxmlformats.org/drawingml/2006/main">
+            <a:off x="476250" y="1952625"/>
+            <a:ext cx="7620000" cy="323850"/>
           </a:xfrm>
           <a:prstGeom xmlns:a="http://schemas.openxmlformats.org/drawingml/2006/main" prst="rect">
             <a:avLst/>
@@ -6508,124 +6338,6 @@
           <a:p xmlns:a="http://schemas.openxmlformats.org/drawingml/2006/main">
             <a:pPr algn="l">
               <a:buNone/>
-              <a:defRPr sz="900" b="1">
-                <a:solidFill>
-                  <a:srgbClr val="006C49"/>
-                </a:solidFill>
-                <a:latin typeface="Helvetica Neue"/>
-                <a:ea typeface="Helvetica Neue"/>
-                <a:cs typeface="Helvetica Neue"/>
-              </a:defRPr>
-            </a:pPr>
-            <a:r>
-              <a:rPr sz="900" b="1">
-                <a:solidFill>
-                  <a:srgbClr val="006C49"/>
-                </a:solidFill>
-                <a:latin typeface="Helvetica Neue"/>
-                <a:ea typeface="Helvetica Neue"/>
-                <a:cs typeface="Helvetica Neue"/>
-              </a:rPr>
-              <a:t>ROADMAP / TRADE → WAREHOUSE</a:t>
-            </a:r>
-          </a:p>
-        </p:txBody>
-      </p:sp>
-      <p:sp>
-        <p:nvSpPr>
-          <p:cNvPr id="5" name="">
-            <a:extLst xmlns:a="http://schemas.openxmlformats.org/drawingml/2006/main">
-              <a:ext uri="{FF2B5EF4-FFF2-40B4-BE49-F238E27FC236}">
-                <a16:creationId xmlns:a16="http://schemas.microsoft.com/office/drawing/2014/main" id="{DA322289-4A4D-418B-8529-F1B5352ABE84}"/>
-              </a:ext>
-            </a:extLst>
-          </p:cNvPr>
-          <p:cNvSpPr>
-            <a:spLocks xmlns:a="http://schemas.openxmlformats.org/drawingml/2006/main" noGrp="1"/>
-          </p:cNvSpPr>
-          <p:nvPr/>
-        </p:nvSpPr>
-        <p:spPr>
-          <a:xfrm xmlns:a="http://schemas.openxmlformats.org/drawingml/2006/main">
-            <a:off x="476250" y="1381125"/>
-            <a:ext cx="8953500" cy="523875"/>
-          </a:xfrm>
-          <a:prstGeom xmlns:a="http://schemas.openxmlformats.org/drawingml/2006/main" prst="rect">
-            <a:avLst/>
-          </a:prstGeom>
-          <a:noFill xmlns:a="http://schemas.openxmlformats.org/drawingml/2006/main"/>
-          <a:ln xmlns:a="http://schemas.openxmlformats.org/drawingml/2006/main" w="0">
-            <a:noFill/>
-            <a:prstDash val="solid"/>
-          </a:ln>
-        </p:spPr>
-        <p:txBody>
-          <a:bodyPr xmlns:a="http://schemas.openxmlformats.org/drawingml/2006/main" wrap="square" lIns="0" tIns="0" rIns="0" bIns="0" anchor="t">
-            <a:normAutofit fontScale="100000"/>
-          </a:bodyPr>
-          <a:lstStyle xmlns:a="http://schemas.openxmlformats.org/drawingml/2006/main"/>
-          <a:p xmlns:a="http://schemas.openxmlformats.org/drawingml/2006/main">
-            <a:pPr algn="l">
-              <a:buNone/>
-              <a:defRPr sz="3000" b="1">
-                <a:solidFill>
-                  <a:srgbClr val="111613"/>
-                </a:solidFill>
-                <a:latin typeface="Helvetica Neue"/>
-                <a:ea typeface="Helvetica Neue"/>
-                <a:cs typeface="Helvetica Neue"/>
-              </a:defRPr>
-            </a:pPr>
-            <a:r>
-              <a:rPr sz="3000" b="1">
-                <a:solidFill>
-                  <a:srgbClr val="111613"/>
-                </a:solidFill>
-                <a:latin typeface="Helvetica Neue"/>
-                <a:ea typeface="Helvetica Neue"/>
-                <a:cs typeface="Helvetica Neue"/>
-              </a:rPr>
-              <a:t>From trade assistant to fulfilment network.</a:t>
-            </a:r>
-          </a:p>
-        </p:txBody>
-      </p:sp>
-      <p:sp>
-        <p:nvSpPr>
-          <p:cNvPr id="6" name="">
-            <a:extLst xmlns:a="http://schemas.openxmlformats.org/drawingml/2006/main">
-              <a:ext uri="{FF2B5EF4-FFF2-40B4-BE49-F238E27FC236}">
-                <a16:creationId xmlns:a16="http://schemas.microsoft.com/office/drawing/2014/main" id="{52257E59-F1EB-4CE1-A064-AE5DC05B751F}"/>
-              </a:ext>
-            </a:extLst>
-          </p:cNvPr>
-          <p:cNvSpPr>
-            <a:spLocks xmlns:a="http://schemas.openxmlformats.org/drawingml/2006/main" noGrp="1"/>
-          </p:cNvSpPr>
-          <p:nvPr/>
-        </p:nvSpPr>
-        <p:spPr>
-          <a:xfrm xmlns:a="http://schemas.openxmlformats.org/drawingml/2006/main">
-            <a:off x="476250" y="1952625"/>
-            <a:ext cx="7620000" cy="323850"/>
-          </a:xfrm>
-          <a:prstGeom xmlns:a="http://schemas.openxmlformats.org/drawingml/2006/main" prst="rect">
-            <a:avLst/>
-          </a:prstGeom>
-          <a:noFill xmlns:a="http://schemas.openxmlformats.org/drawingml/2006/main"/>
-          <a:ln xmlns:a="http://schemas.openxmlformats.org/drawingml/2006/main" w="0">
-            <a:noFill/>
-            <a:prstDash val="solid"/>
-          </a:ln>
-        </p:spPr>
-        <p:txBody>
-          <a:bodyPr xmlns:a="http://schemas.openxmlformats.org/drawingml/2006/main" wrap="square" lIns="0" tIns="0" rIns="0" bIns="0" anchor="t">
-            <a:normAutofit fontScale="100000"/>
-          </a:bodyPr>
-          <a:lstStyle xmlns:a="http://schemas.openxmlformats.org/drawingml/2006/main"/>
-          <a:p xmlns:a="http://schemas.openxmlformats.org/drawingml/2006/main">
-            <a:pPr algn="l">
-              <a:buNone/>
               <a:defRPr sz="1350" b="0">
                 <a:solidFill>
                   <a:srgbClr val="66706A"/>
@@ -6644,7 +6356,7 @@
                 <a:ea typeface="Helvetica Neue"/>
                 <a:cs typeface="Helvetica Neue"/>
               </a:rPr>
-              <a:t>Orders become promises. Deliveries become movement. The ledger stays the truth.</a:t>
+              <a:t>Roadmap expectations—not capabilities claimed in today’s production product.</a:t>
             </a:r>
           </a:p>
         </p:txBody>
@@ -6738,7 +6450,7 @@
                 <a:ea typeface="Helvetica Neue"/>
                 <a:cs typeface="Helvetica Neue"/>
               </a:rPr>
-              <a:t>01 / ORDERS</a:t>
+              <a:t>IN DEVELOPMENT / ORDERS</a:t>
             </a:r>
           </a:p>
         </p:txBody>
@@ -6950,7 +6662,7 @@
                 <a:ea typeface="Helvetica Neue"/>
                 <a:cs typeface="Helvetica Neue"/>
               </a:rPr>
-              <a:t>02 / DELIVERY</a:t>
+              <a:t>PLANNED / DELIVERY</a:t>
             </a:r>
           </a:p>
         </p:txBody>
@@ -7162,7 +6874,7 @@
                 <a:ea typeface="Helvetica Neue"/>
                 <a:cs typeface="Helvetica Neue"/>
               </a:rPr>
-              <a:t>03 / RESTOCK</a:t>
+              <a:t>PLANNED / SUPPLIER RESTOCK</a:t>
             </a:r>
           </a:p>
         </p:txBody>
@@ -7350,7 +7062,7 @@
         </p:spPr>
         <p:txBody>
           <a:bodyPr xmlns:a="http://schemas.openxmlformats.org/drawingml/2006/main" wrap="square" lIns="0" tIns="0" rIns="0" bIns="0" anchor="t">
-            <a:normAutofit fontScale="100000"/>
+            <a:normAutofit fontScale="98432"/>
           </a:bodyPr>
           <a:lstStyle xmlns:a="http://schemas.openxmlformats.org/drawingml/2006/main"/>
           <a:p xmlns:a="http://schemas.openxmlformats.org/drawingml/2006/main">
@@ -7374,7 +7086,7 @@
                 <a:ea typeface="Helvetica Neue"/>
                 <a:cs typeface="Helvetica Neue"/>
               </a:rPr>
-              <a:t>04 / WAREHOUSE SCALE</a:t>
+              <a:t>LONGER TERM / WAREHOUSE SCALE</a:t>
             </a:r>
           </a:p>
         </p:txBody>
@@ -7584,7 +7296,7 @@
                 <a:ea typeface="Helvetica Neue"/>
                 <a:cs typeface="Helvetica Neue"/>
               </a:rPr>
-              <a:t>“Hey Chhotu…”</a:t>
+              <a:t>FUTURE CONCEPT: “Hey Chhotu…”</a:t>
             </a:r>
           </a:p>
         </p:txBody>
@@ -7643,7 +7355,7 @@
                 <a:ea typeface="Helvetica Neue"/>
                 <a:cs typeface="Helvetica Neue"/>
               </a:rPr>
-              <a:t>OPT-IN WAKE WORD  •  ON-DEVICE TRIGGER  •  FUTURE</a:t>
+              <a:t>OPT-IN WAKE WORD  •  ON-DEVICE TRIGGER</a:t>
             </a:r>
           </a:p>
         </p:txBody>
@@ -7703,6 +7415,114 @@
                 <a:cs typeface="Helvetica Neue"/>
               </a:rPr>
               <a:t>05</a:t>
+            </a:r>
+          </a:p>
+        </p:txBody>
+      </p:sp>
+      <p:pic>
+        <p:nvPicPr>
+          <p:cNvPr id="59" name=""/>
+          <p:cNvPicPr>
+            <a:picLocks xmlns:a="http://schemas.openxmlformats.org/drawingml/2006/main" noChangeAspect="1"/>
+          </p:cNvPicPr>
+          <p:nvPr/>
+        </p:nvPicPr>
+        <p:blipFill>
+          <a:blip xmlns:r="http://schemas.openxmlformats.org/officeDocument/2006/relationships" xmlns:a="http://schemas.openxmlformats.org/drawingml/2006/main" r:embed="Rbea1e3e99ca948e0"/>
+          <a:stretch xmlns:a="http://schemas.openxmlformats.org/drawingml/2006/main"/>
+        </p:blipFill>
+        <p:spPr>
+          <a:xfrm xmlns:a="http://schemas.openxmlformats.org/drawingml/2006/main">
+            <a:off x="476250" y="342900"/>
+            <a:ext cx="266700" cy="266700"/>
+          </a:xfrm>
+          <a:prstGeom xmlns:a="http://schemas.openxmlformats.org/drawingml/2006/main" prst="rect">
+            <a:avLst/>
+          </a:prstGeom>
+        </p:spPr>
+      </p:pic>
+      <p:pic>
+        <p:nvPicPr>
+          <p:cNvPr id="60" name=""/>
+          <p:cNvPicPr>
+            <a:picLocks xmlns:a="http://schemas.openxmlformats.org/drawingml/2006/main" noChangeAspect="1"/>
+          </p:cNvPicPr>
+          <p:nvPr/>
+        </p:nvPicPr>
+        <p:blipFill>
+          <a:blip xmlns:r="http://schemas.openxmlformats.org/officeDocument/2006/relationships" xmlns:a="http://schemas.openxmlformats.org/drawingml/2006/main" r:embed="R83637e72e58d47b4"/>
+          <a:stretch xmlns:a="http://schemas.openxmlformats.org/drawingml/2006/main"/>
+        </p:blipFill>
+        <p:spPr>
+          <a:xfrm xmlns:a="http://schemas.openxmlformats.org/drawingml/2006/main">
+            <a:off x="476250" y="342900"/>
+            <a:ext cx="266700" cy="266700"/>
+          </a:xfrm>
+          <a:prstGeom xmlns:a="http://schemas.openxmlformats.org/drawingml/2006/main" prst="rect">
+            <a:avLst/>
+          </a:prstGeom>
+        </p:spPr>
+      </p:pic>
+      <p:sp>
+        <p:nvSpPr>
+          <p:cNvPr id="35" name="Chhotu.ai wordmark">
+            <a:extLst xmlns:a="http://schemas.openxmlformats.org/drawingml/2006/main">
+              <a:ext uri="{FF2B5EF4-FFF2-40B4-BE49-F238E27FC236}">
+                <a16:creationId xmlns:a16="http://schemas.microsoft.com/office/drawing/2014/main" id="{4D480302-C551-4950-801E-98D24102AB12}"/>
+              </a:ext>
+            </a:extLst>
+          </p:cNvPr>
+          <p:cNvSpPr>
+            <a:spLocks xmlns:a="http://schemas.openxmlformats.org/drawingml/2006/main" noGrp="1"/>
+          </p:cNvSpPr>
+          <p:nvPr/>
+        </p:nvSpPr>
+        <p:spPr>
+          <a:xfrm xmlns:a="http://schemas.openxmlformats.org/drawingml/2006/main">
+            <a:off x="800100" y="314325"/>
+            <a:ext cx="1066800" cy="323850"/>
+          </a:xfrm>
+          <a:prstGeom xmlns:a="http://schemas.openxmlformats.org/drawingml/2006/main" prst="rect">
+            <a:avLst/>
+          </a:prstGeom>
+          <a:noFill xmlns:a="http://schemas.openxmlformats.org/drawingml/2006/main"/>
+          <a:ln xmlns:a="http://schemas.openxmlformats.org/drawingml/2006/main" w="0">
+            <a:noFill/>
+            <a:prstDash val="solid"/>
+          </a:ln>
+        </p:spPr>
+        <p:txBody>
+          <a:bodyPr xmlns:a="http://schemas.openxmlformats.org/drawingml/2006/main" anchor="ctr"/>
+          <a:lstStyle xmlns:a="http://schemas.openxmlformats.org/drawingml/2006/main"/>
+          <a:p xmlns:a="http://schemas.openxmlformats.org/drawingml/2006/main">
+            <a:pPr>
+              <a:defRPr sz="1500">
+                <a:latin typeface="Arial"/>
+                <a:ea typeface="Arial"/>
+                <a:cs typeface="Arial"/>
+              </a:defRPr>
+            </a:pPr>
+            <a:r>
+              <a:rPr sz="1500" b="1">
+                <a:solidFill>
+                  <a:srgbClr val="111814"/>
+                </a:solidFill>
+                <a:latin typeface="Arial"/>
+                <a:ea typeface="Arial"/>
+                <a:cs typeface="Arial"/>
+              </a:rPr>
+              <a:t>Chhotu</a:t>
+            </a:r>
+            <a:r>
+              <a:rPr sz="1500" b="1">
+                <a:solidFill>
+                  <a:srgbClr val="00865F"/>
+                </a:solidFill>
+                <a:latin typeface="Arial"/>
+                <a:ea typeface="Arial"/>
+                <a:cs typeface="Arial"/>
+              </a:rPr>
+              <a:t>.ai</a:t>
             </a:r>
           </a:p>
         </p:txBody>

</xml_diff>